<commit_message>
Migrate Week 3 from Power BI to Tableau, add dashboard design section and cheat sheet
</commit_message>
<xml_diff>
--- a/week-03-tableau/slides/week-03-slides.pptx
+++ b/week-03-tableau/slides/week-03-slides.pptx
@@ -12,9 +12,10 @@
     <p:sldId id="260" r:id="rId6"/>
     <p:sldId id="261" r:id="rId7"/>
     <p:sldId id="262" r:id="rId8"/>
+    <p:sldId id="263" r:id="rId9"/>
   </p:sldIdLst>
   <p:notesMasterIdLst>
-    <p:notesMasterId r:id="rId9"/>
+    <p:notesMasterId r:id="rId10"/>
   </p:notesMasterIdLst>
   <p:sldSz cx="12192000" cy="6858000"/>
   <p:notesSz cx="6858000" cy="12192000"/>
@@ -1060,6 +1061,94 @@
             <a:fld id="{F7021451-1387-4CA6-816F-3879F97B5CBC}" type="slidenum">
               <a:rPr lang="en-US"/>
               <a:t>7</a:t>
+            </a:fld>
+            <a:endParaRPr lang="en-US"/>
+          </a:p>
+        </p:txBody>
+      </p:sp>
+    </p:spTree>
+    <p:extLst>
+      <p:ext uri="{BB962C8B-B14F-4D97-AF65-F5344CB8AC3E}">
+        <p14:creationId xmlns:p14="http://schemas.microsoft.com/office/powerpoint/2010/main" val="1024086991"/>
+      </p:ext>
+    </p:extLst>
+  </p:cSld>
+  <p:clrMapOvr>
+    <a:masterClrMapping/>
+  </p:clrMapOvr>
+</p:notes>
+</file>
+
+<file path=ppt/notesSlides/notesSlide8.xml><?xml version="1.0" encoding="utf-8"?>
+<p:notes xmlns:a="http://schemas.openxmlformats.org/drawingml/2006/main" xmlns:r="http://schemas.openxmlformats.org/officeDocument/2006/relationships" xmlns:p="http://schemas.openxmlformats.org/presentationml/2006/main">
+  <p:cSld>
+    <p:spTree>
+      <p:nvGrpSpPr>
+        <p:cNvPr id="1" name=""/>
+        <p:cNvGrpSpPr/>
+        <p:nvPr/>
+      </p:nvGrpSpPr>
+      <p:grpSpPr>
+        <a:xfrm>
+          <a:off x="0" y="0"/>
+          <a:ext cx="0" cy="0"/>
+          <a:chOff x="0" y="0"/>
+          <a:chExt cx="0" cy="0"/>
+        </a:xfrm>
+      </p:grpSpPr>
+      <p:sp>
+        <p:nvSpPr>
+          <p:cNvPr id="2" name="Slide Image Placeholder 1"/>
+          <p:cNvSpPr>
+            <a:spLocks noGrp="1" noRot="1" noChangeAspect="1"/>
+          </p:cNvSpPr>
+          <p:nvPr>
+            <p:ph type="sldImg"/>
+          </p:nvPr>
+        </p:nvSpPr>
+        <p:spPr/>
+      </p:sp>
+      <p:sp>
+        <p:nvSpPr>
+          <p:cNvPr id="3" name="Notes Placeholder 2"/>
+          <p:cNvSpPr>
+            <a:spLocks noGrp="1"/>
+          </p:cNvSpPr>
+          <p:nvPr>
+            <p:ph type="body" idx="1"/>
+          </p:nvPr>
+        </p:nvSpPr>
+        <p:spPr/>
+        <p:txBody>
+          <a:bodyPr/>
+          <a:lstStyle/>
+          <a:p>
+            <a:r>
+              <a:rPr lang="en-US" dirty="0"/>
+              <a:t/>
+            </a:r>
+            <a:endParaRPr lang="en-US" dirty="0"/>
+          </a:p>
+        </p:txBody>
+      </p:sp>
+      <p:sp>
+        <p:nvSpPr>
+          <p:cNvPr id="4" name="Slide Number Placeholder 3"/>
+          <p:cNvSpPr>
+            <a:spLocks noGrp="1"/>
+          </p:cNvSpPr>
+          <p:nvPr>
+            <p:ph type="sldNum" sz="quarter" idx="10"/>
+          </p:nvPr>
+        </p:nvSpPr>
+        <p:spPr/>
+        <p:txBody>
+          <a:bodyPr/>
+          <a:lstStyle/>
+          <a:p>
+            <a:fld id="{F7021451-1387-4CA6-816F-3879F97B5CBC}" type="slidenum">
+              <a:rPr lang="en-US"/>
+              <a:t>8</a:t>
             </a:fld>
             <a:endParaRPr lang="en-US"/>
           </a:p>
@@ -1391,7 +1480,7 @@
     <p:bg>
       <p:bgPr>
         <a:solidFill>
-          <a:srgbClr val="1B3A34"/>
+          <a:srgbClr val="1C3F60"/>
         </a:solidFill>
       </p:bgPr>
     </p:bg>
@@ -1456,7 +1545,7 @@
         </p:nvSpPr>
         <p:spPr>
           <a:xfrm>
-            <a:off x="640080" y="2377440"/>
+            <a:off x="640080" y="2286000"/>
             <a:ext cx="10515600" cy="1645920"/>
           </a:xfrm>
           <a:prstGeom prst="rect">
@@ -1512,7 +1601,7 @@
         </p:nvSpPr>
         <p:spPr>
           <a:xfrm>
-            <a:off x="640080" y="3749040"/>
+            <a:off x="640080" y="3657600"/>
             <a:ext cx="10058400" cy="731520"/>
           </a:xfrm>
           <a:prstGeom prst="rect">
@@ -1531,13 +1620,13 @@
             <a:r>
               <a:rPr lang="en-US" sz="1800" dirty="0">
                 <a:solidFill>
-                  <a:srgbClr val="D8E4E0"/>
+                  <a:srgbClr val="D6E2EA"/>
                 </a:solidFill>
                 <a:latin typeface="Calibri" pitchFamily="34" charset="0"/>
                 <a:ea typeface="Calibri" pitchFamily="34" charset="-122"/>
                 <a:cs typeface="Calibri" pitchFamily="34" charset="-120"/>
               </a:rPr>
-              <a:t>DSDG Data Analytics — Week 3 · Power BI</a:t>
+              <a:t>DSDG Data Analytics — Week 3 · Tableau</a:t>
             </a:r>
             <a:endParaRPr lang="en-US" sz="1800" dirty="0"/>
           </a:p>
@@ -1551,7 +1640,7 @@
         </p:nvSpPr>
         <p:spPr>
           <a:xfrm>
-            <a:off x="640080" y="2148840"/>
+            <a:off x="640080" y="2057400"/>
             <a:ext cx="1280160" cy="45720"/>
           </a:xfrm>
           <a:prstGeom prst="rect">
@@ -1659,35 +1748,72 @@
               <a:buNone/>
             </a:pPr>
             <a:r>
-              <a:rPr lang="en-US" sz="2700" b="1" dirty="0">
-                <a:solidFill>
-                  <a:srgbClr val="1B3A34"/>
+              <a:rPr lang="en-US" sz="2600" b="1" dirty="0">
+                <a:solidFill>
+                  <a:srgbClr val="1C3F60"/>
                 </a:solidFill>
                 <a:latin typeface="Georgia" pitchFamily="34" charset="0"/>
                 <a:ea typeface="Georgia" pitchFamily="34" charset="-122"/>
                 <a:cs typeface="Georgia" pitchFamily="34" charset="-120"/>
               </a:rPr>
-              <a:t>A logistics note</a:t>
-            </a:r>
-            <a:endParaRPr lang="en-US" sz="2700" dirty="0"/>
-          </a:p>
-        </p:txBody>
-      </p:sp>
-      <p:sp>
-        <p:nvSpPr>
-          <p:cNvPr id="4" name="Shape 2"/>
-          <p:cNvSpPr/>
-          <p:nvPr/>
-        </p:nvSpPr>
-        <p:spPr>
-          <a:xfrm>
-            <a:off x="640080" y="2011680"/>
-            <a:ext cx="10881360" cy="1463040"/>
-          </a:xfrm>
-          <a:prstGeom prst="roundRect">
-            <a:avLst>
-              <a:gd name="adj" fmla="val 3750"/>
-            </a:avLst>
+              <a:t>Tableau Public — free, Mac or Windows</a:t>
+            </a:r>
+            <a:endParaRPr lang="en-US" sz="2600" dirty="0"/>
+          </a:p>
+        </p:txBody>
+      </p:sp>
+      <p:sp>
+        <p:nvSpPr>
+          <p:cNvPr id="4" name="Text 2"/>
+          <p:cNvSpPr/>
+          <p:nvPr/>
+        </p:nvSpPr>
+        <p:spPr>
+          <a:xfrm>
+            <a:off x="640080" y="1965960"/>
+            <a:ext cx="10058400" cy="548640"/>
+          </a:xfrm>
+          <a:prstGeom prst="rect">
+            <a:avLst/>
+          </a:prstGeom>
+          <a:noFill/>
+          <a:ln/>
+        </p:spPr>
+        <p:txBody>
+          <a:bodyPr wrap="square" rtlCol="0" anchor="ctr"/>
+          <a:lstStyle/>
+          <a:p>
+            <a:pPr indent="0" marL="0">
+              <a:buNone/>
+            </a:pPr>
+            <a:r>
+              <a:rPr lang="en-US" sz="1800" b="1" dirty="0">
+                <a:solidFill>
+                  <a:srgbClr val="1C3F60"/>
+                </a:solidFill>
+                <a:latin typeface="Calibri" pitchFamily="34" charset="0"/>
+                <a:ea typeface="Calibri" pitchFamily="34" charset="-122"/>
+                <a:cs typeface="Calibri" pitchFamily="34" charset="-120"/>
+              </a:rPr>
+              <a:t>Install it before the session, not during: public.tableau.com</a:t>
+            </a:r>
+            <a:endParaRPr lang="en-US" sz="1800" dirty="0"/>
+          </a:p>
+        </p:txBody>
+      </p:sp>
+      <p:sp>
+        <p:nvSpPr>
+          <p:cNvPr id="5" name="Shape 3"/>
+          <p:cNvSpPr/>
+          <p:nvPr/>
+        </p:nvSpPr>
+        <p:spPr>
+          <a:xfrm>
+            <a:off x="640080" y="2743200"/>
+            <a:ext cx="10881360" cy="1188720"/>
+          </a:xfrm>
+          <a:prstGeom prst="rect">
+            <a:avLst/>
           </a:prstGeom>
           <a:solidFill>
             <a:srgbClr val="F4F1EC"/>
@@ -1697,14 +1823,14 @@
       </p:sp>
       <p:sp>
         <p:nvSpPr>
-          <p:cNvPr id="5" name="Text 3"/>
-          <p:cNvSpPr/>
-          <p:nvPr/>
-        </p:nvSpPr>
-        <p:spPr>
-          <a:xfrm>
-            <a:off x="1005840" y="2212848"/>
-            <a:ext cx="10149840" cy="457200"/>
+          <p:cNvPr id="6" name="Text 4"/>
+          <p:cNvSpPr/>
+          <p:nvPr/>
+        </p:nvSpPr>
+        <p:spPr>
+          <a:xfrm>
+            <a:off x="914400" y="2926080"/>
+            <a:ext cx="10332720" cy="868680"/>
           </a:xfrm>
           <a:prstGeom prst="rect">
             <a:avLst/>
@@ -1720,95 +1846,17 @@
               <a:buNone/>
             </a:pPr>
             <a:r>
-              <a:rPr lang="en-US" sz="1800" b="1" dirty="0">
-                <a:solidFill>
-                  <a:srgbClr val="1B3A34"/>
+              <a:rPr lang="en-US" sz="1400" dirty="0">
+                <a:solidFill>
+                  <a:srgbClr val="2A2A2A"/>
                 </a:solidFill>
                 <a:latin typeface="Calibri" pitchFamily="34" charset="0"/>
                 <a:ea typeface="Calibri" pitchFamily="34" charset="-122"/>
                 <a:cs typeface="Calibri" pitchFamily="34" charset="-120"/>
               </a:rPr>
-              <a:t>Power BI Desktop is Windows-only.</a:t>
-            </a:r>
-            <a:endParaRPr lang="en-US" sz="1800" dirty="0"/>
-          </a:p>
-        </p:txBody>
-      </p:sp>
-      <p:sp>
-        <p:nvSpPr>
-          <p:cNvPr id="6" name="Text 4"/>
-          <p:cNvSpPr/>
-          <p:nvPr/>
-        </p:nvSpPr>
-        <p:spPr>
-          <a:xfrm>
-            <a:off x="1005840" y="2697480"/>
-            <a:ext cx="10149840" cy="548640"/>
-          </a:xfrm>
-          <a:prstGeom prst="rect">
-            <a:avLst/>
-          </a:prstGeom>
-          <a:noFill/>
-          <a:ln/>
-        </p:spPr>
-        <p:txBody>
-          <a:bodyPr wrap="square" rtlCol="0" anchor="ctr"/>
-          <a:lstStyle/>
-          <a:p>
-            <a:pPr indent="0" marL="0">
-              <a:buNone/>
-            </a:pPr>
-            <a:r>
-              <a:rPr lang="en-US" sz="1400" dirty="0">
-                <a:solidFill>
-                  <a:srgbClr val="2A2A2A"/>
-                </a:solidFill>
-                <a:latin typeface="Calibri" pitchFamily="34" charset="0"/>
-                <a:ea typeface="Calibri" pitchFamily="34" charset="-122"/>
-                <a:cs typeface="Calibri" pitchFamily="34" charset="-120"/>
-              </a:rPr>
-              <a:t>Mac users: pair with a Windows laptop, or use the browser-based Power BI Service.</a:t>
+              <a:t>One trade-off: Tableau Public saves workbooks to Tableau's public servers, visible to anyone. Fine for today's dataset — worth knowing before you publish something later you'd rather keep private.</a:t>
             </a:r>
             <a:endParaRPr lang="en-US" sz="1400" dirty="0"/>
-          </a:p>
-        </p:txBody>
-      </p:sp>
-      <p:sp>
-        <p:nvSpPr>
-          <p:cNvPr id="7" name="Text 5"/>
-          <p:cNvSpPr/>
-          <p:nvPr/>
-        </p:nvSpPr>
-        <p:spPr>
-          <a:xfrm>
-            <a:off x="640080" y="3794760"/>
-            <a:ext cx="9144000" cy="365760"/>
-          </a:xfrm>
-          <a:prstGeom prst="rect">
-            <a:avLst/>
-          </a:prstGeom>
-          <a:noFill/>
-          <a:ln/>
-        </p:spPr>
-        <p:txBody>
-          <a:bodyPr wrap="square" rtlCol="0" anchor="ctr"/>
-          <a:lstStyle/>
-          <a:p>
-            <a:pPr indent="0" marL="0">
-              <a:buNone/>
-            </a:pPr>
-            <a:r>
-              <a:rPr lang="en-US" sz="1200" i="1" dirty="0">
-                <a:solidFill>
-                  <a:srgbClr val="6B6B6B"/>
-                </a:solidFill>
-                <a:latin typeface="Calibri" pitchFamily="34" charset="0"/>
-                <a:ea typeface="Calibri" pitchFamily="34" charset="-122"/>
-                <a:cs typeface="Calibri" pitchFamily="34" charset="-120"/>
-              </a:rPr>
-              <a:t>Full breakdown: resources/power-bi-setup-notes.md</a:t>
-            </a:r>
-            <a:endParaRPr lang="en-US" sz="1200" dirty="0"/>
           </a:p>
         </p:txBody>
       </p:sp>
@@ -1877,7 +1925,7 @@
                 <a:ea typeface="Calibri" pitchFamily="34" charset="-122"/>
                 <a:cs typeface="Calibri" pitchFamily="34" charset="-120"/>
               </a:rPr>
-              <a:t>LAST WEEK → THIS WEEK</a:t>
+              <a:t>WHAT ANALYSTS BUILD DASHBOARDS FOR</a:t>
             </a:r>
             <a:endParaRPr lang="en-US" sz="1200" dirty="0"/>
           </a:p>
@@ -1908,30 +1956,50 @@
               <a:buNone/>
             </a:pPr>
             <a:r>
-              <a:rPr lang="en-US" sz="2700" b="1" dirty="0">
-                <a:solidFill>
-                  <a:srgbClr val="1B3A34"/>
+              <a:rPr lang="en-US" sz="2600" b="1" dirty="0">
+                <a:solidFill>
+                  <a:srgbClr val="1C3F60"/>
                 </a:solidFill>
                 <a:latin typeface="Georgia" pitchFamily="34" charset="0"/>
                 <a:ea typeface="Georgia" pitchFamily="34" charset="-122"/>
                 <a:cs typeface="Georgia" pitchFamily="34" charset="-120"/>
               </a:rPr>
-              <a:t>A spreadsheet finding vs. a dashboard</a:t>
-            </a:r>
-            <a:endParaRPr lang="en-US" sz="2700" dirty="0"/>
-          </a:p>
-        </p:txBody>
-      </p:sp>
-      <p:sp>
-        <p:nvSpPr>
-          <p:cNvPr id="4" name="Text 2"/>
-          <p:cNvSpPr/>
-          <p:nvPr/>
-        </p:nvSpPr>
-        <p:spPr>
-          <a:xfrm>
-            <a:off x="640080" y="2103120"/>
-            <a:ext cx="10058400" cy="1188720"/>
+              <a:t>Two different jobs</a:t>
+            </a:r>
+            <a:endParaRPr lang="en-US" sz="2600" dirty="0"/>
+          </a:p>
+        </p:txBody>
+      </p:sp>
+      <p:sp>
+        <p:nvSpPr>
+          <p:cNvPr id="4" name="Shape 2"/>
+          <p:cNvSpPr/>
+          <p:nvPr/>
+        </p:nvSpPr>
+        <p:spPr>
+          <a:xfrm>
+            <a:off x="640080" y="1965960"/>
+            <a:ext cx="5257800" cy="3383280"/>
+          </a:xfrm>
+          <a:prstGeom prst="rect">
+            <a:avLst/>
+          </a:prstGeom>
+          <a:solidFill>
+            <a:srgbClr val="1C3F60"/>
+          </a:solidFill>
+          <a:ln/>
+        </p:spPr>
+      </p:sp>
+      <p:sp>
+        <p:nvSpPr>
+          <p:cNvPr id="5" name="Text 3"/>
+          <p:cNvSpPr/>
+          <p:nvPr/>
+        </p:nvSpPr>
+        <p:spPr>
+          <a:xfrm>
+            <a:off x="914400" y="2240280"/>
+            <a:ext cx="4709160" cy="365760"/>
           </a:xfrm>
           <a:prstGeom prst="rect">
             <a:avLst/>
@@ -1947,56 +2015,193 @@
               <a:buNone/>
             </a:pPr>
             <a:r>
-              <a:rPr lang="en-US" sz="2000" i="1" dirty="0">
-                <a:solidFill>
-                  <a:srgbClr val="1B3A34"/>
-                </a:solidFill>
-                <a:latin typeface="Georgia" pitchFamily="34" charset="0"/>
-                <a:ea typeface="Georgia" pitchFamily="34" charset="-122"/>
-                <a:cs typeface="Georgia" pitchFamily="34" charset="-120"/>
-              </a:rPr>
-              <a:t>“That sentence is true, but if you handed someone a spreadsheet and said ‘trust me,’ they'd have to redo your work to believe you.”</a:t>
-            </a:r>
-            <a:endParaRPr lang="en-US" sz="2000" dirty="0"/>
-          </a:p>
-        </p:txBody>
-      </p:sp>
-      <p:sp>
-        <p:nvSpPr>
-          <p:cNvPr id="5" name="Text 3"/>
-          <p:cNvSpPr/>
-          <p:nvPr/>
-        </p:nvSpPr>
-        <p:spPr>
-          <a:xfrm>
-            <a:off x="640080" y="3429000"/>
-            <a:ext cx="9875520" cy="914400"/>
-          </a:xfrm>
-          <a:prstGeom prst="rect">
-            <a:avLst/>
-          </a:prstGeom>
-          <a:noFill/>
-          <a:ln/>
-        </p:spPr>
-        <p:txBody>
-          <a:bodyPr wrap="square" rtlCol="0" anchor="ctr"/>
-          <a:lstStyle/>
-          <a:p>
-            <a:pPr indent="0" marL="0">
-              <a:buNone/>
-            </a:pPr>
-            <a:r>
-              <a:rPr lang="en-US" sz="1600" b="1" dirty="0">
-                <a:solidFill>
-                  <a:srgbClr val="2A2A2A"/>
+              <a:rPr lang="en-US" sz="1200" b="1" spc="150" kern="0" dirty="0">
+                <a:solidFill>
+                  <a:srgbClr val="D97E3F"/>
                 </a:solidFill>
                 <a:latin typeface="Calibri" pitchFamily="34" charset="0"/>
                 <a:ea typeface="Calibri" pitchFamily="34" charset="-122"/>
                 <a:cs typeface="Calibri" pitchFamily="34" charset="-120"/>
               </a:rPr>
-              <a:t>A dashboard lets someone check your claim themselves, in about ten seconds. That's the whole point of today.</a:t>
-            </a:r>
-            <a:endParaRPr lang="en-US" sz="1600" dirty="0"/>
+              <a:t>EXECUTIVE</a:t>
+            </a:r>
+            <a:endParaRPr lang="en-US" sz="1200" dirty="0"/>
+          </a:p>
+        </p:txBody>
+      </p:sp>
+      <p:sp>
+        <p:nvSpPr>
+          <p:cNvPr id="6" name="Text 4"/>
+          <p:cNvSpPr/>
+          <p:nvPr/>
+        </p:nvSpPr>
+        <p:spPr>
+          <a:xfrm>
+            <a:off x="914400" y="2697480"/>
+            <a:ext cx="4709160" cy="2286000"/>
+          </a:xfrm>
+          <a:prstGeom prst="rect">
+            <a:avLst/>
+          </a:prstGeom>
+          <a:noFill/>
+          <a:ln/>
+        </p:spPr>
+        <p:txBody>
+          <a:bodyPr wrap="square" rtlCol="0" anchor="t"/>
+          <a:lstStyle/>
+          <a:p>
+            <a:pPr indent="0" marL="0">
+              <a:buNone/>
+            </a:pPr>
+            <a:r>
+              <a:rPr lang="en-US" sz="1500" dirty="0">
+                <a:solidFill>
+                  <a:srgbClr val="FFFFFF"/>
+                </a:solidFill>
+                <a:latin typeface="Calibri" pitchFamily="34" charset="0"/>
+                <a:ea typeface="Calibri" pitchFamily="34" charset="-122"/>
+                <a:cs typeface="Calibri" pitchFamily="34" charset="-120"/>
+              </a:rPr>
+              <a:t>Looked at for seconds, not minutes. High-level, an obvious “is this good or bad.” Consumed passively.</a:t>
+            </a:r>
+            <a:endParaRPr lang="en-US" sz="1500" dirty="0"/>
+          </a:p>
+        </p:txBody>
+      </p:sp>
+      <p:sp>
+        <p:nvSpPr>
+          <p:cNvPr id="7" name="Shape 5"/>
+          <p:cNvSpPr/>
+          <p:nvPr/>
+        </p:nvSpPr>
+        <p:spPr>
+          <a:xfrm>
+            <a:off x="6263640" y="1965960"/>
+            <a:ext cx="5257800" cy="3383280"/>
+          </a:xfrm>
+          <a:prstGeom prst="rect">
+            <a:avLst/>
+          </a:prstGeom>
+          <a:solidFill>
+            <a:srgbClr val="F4F1EC"/>
+          </a:solidFill>
+          <a:ln/>
+        </p:spPr>
+      </p:sp>
+      <p:sp>
+        <p:nvSpPr>
+          <p:cNvPr id="8" name="Text 6"/>
+          <p:cNvSpPr/>
+          <p:nvPr/>
+        </p:nvSpPr>
+        <p:spPr>
+          <a:xfrm>
+            <a:off x="6537960" y="2240280"/>
+            <a:ext cx="4709160" cy="365760"/>
+          </a:xfrm>
+          <a:prstGeom prst="rect">
+            <a:avLst/>
+          </a:prstGeom>
+          <a:noFill/>
+          <a:ln/>
+        </p:spPr>
+        <p:txBody>
+          <a:bodyPr wrap="square" rtlCol="0" anchor="ctr"/>
+          <a:lstStyle/>
+          <a:p>
+            <a:pPr indent="0" marL="0">
+              <a:buNone/>
+            </a:pPr>
+            <a:r>
+              <a:rPr lang="en-US" sz="1200" b="1" spc="150" kern="0" dirty="0">
+                <a:solidFill>
+                  <a:srgbClr val="D97E3F"/>
+                </a:solidFill>
+                <a:latin typeface="Calibri" pitchFamily="34" charset="0"/>
+                <a:ea typeface="Calibri" pitchFamily="34" charset="-122"/>
+                <a:cs typeface="Calibri" pitchFamily="34" charset="-120"/>
+              </a:rPr>
+              <a:t>ANALYST</a:t>
+            </a:r>
+            <a:endParaRPr lang="en-US" sz="1200" dirty="0"/>
+          </a:p>
+        </p:txBody>
+      </p:sp>
+      <p:sp>
+        <p:nvSpPr>
+          <p:cNvPr id="9" name="Text 7"/>
+          <p:cNvSpPr/>
+          <p:nvPr/>
+        </p:nvSpPr>
+        <p:spPr>
+          <a:xfrm>
+            <a:off x="6537960" y="2697480"/>
+            <a:ext cx="4709160" cy="2286000"/>
+          </a:xfrm>
+          <a:prstGeom prst="rect">
+            <a:avLst/>
+          </a:prstGeom>
+          <a:noFill/>
+          <a:ln/>
+        </p:spPr>
+        <p:txBody>
+          <a:bodyPr wrap="square" rtlCol="0" anchor="t"/>
+          <a:lstStyle/>
+          <a:p>
+            <a:pPr indent="0" marL="0">
+              <a:buNone/>
+            </a:pPr>
+            <a:r>
+              <a:rPr lang="en-US" sz="1500" dirty="0">
+                <a:solidFill>
+                  <a:srgbClr val="2A2A2A"/>
+                </a:solidFill>
+                <a:latin typeface="Calibri" pitchFamily="34" charset="0"/>
+                <a:ea typeface="Calibri" pitchFamily="34" charset="-122"/>
+                <a:cs typeface="Calibri" pitchFamily="34" charset="-120"/>
+              </a:rPr>
+              <a:t>Worked in actively — filtered, drilled into, cross-referenced. Built to hunt down why a number moved.</a:t>
+            </a:r>
+            <a:endParaRPr lang="en-US" sz="1500" dirty="0"/>
+          </a:p>
+        </p:txBody>
+      </p:sp>
+      <p:sp>
+        <p:nvSpPr>
+          <p:cNvPr id="10" name="Text 8"/>
+          <p:cNvSpPr/>
+          <p:nvPr/>
+        </p:nvSpPr>
+        <p:spPr>
+          <a:xfrm>
+            <a:off x="640080" y="5623560"/>
+            <a:ext cx="10515600" cy="457200"/>
+          </a:xfrm>
+          <a:prstGeom prst="rect">
+            <a:avLst/>
+          </a:prstGeom>
+          <a:noFill/>
+          <a:ln/>
+        </p:spPr>
+        <p:txBody>
+          <a:bodyPr wrap="square" rtlCol="0" anchor="ctr"/>
+          <a:lstStyle/>
+          <a:p>
+            <a:pPr indent="0" marL="0">
+              <a:buNone/>
+            </a:pPr>
+            <a:r>
+              <a:rPr lang="en-US" sz="1400" i="1" dirty="0">
+                <a:solidFill>
+                  <a:srgbClr val="6B6B6B"/>
+                </a:solidFill>
+                <a:latin typeface="Calibri" pitchFamily="34" charset="0"/>
+                <a:ea typeface="Calibri" pitchFamily="34" charset="-122"/>
+                <a:cs typeface="Calibri" pitchFamily="34" charset="-120"/>
+              </a:rPr>
+              <a:t>A dashboard trying to be both usually fails at both. Know which one you're building.</a:t>
+            </a:r>
+            <a:endParaRPr lang="en-US" sz="1400" dirty="0"/>
           </a:p>
         </p:txBody>
       </p:sp>
@@ -2065,7 +2270,7 @@
                 <a:ea typeface="Calibri" pitchFamily="34" charset="-122"/>
                 <a:cs typeface="Calibri" pitchFamily="34" charset="-120"/>
               </a:rPr>
-              <a:t>ORIENTATION</a:t>
+              <a:t>GOOD VS. BUSY</a:t>
             </a:r>
             <a:endParaRPr lang="en-US" sz="1200" dirty="0"/>
           </a:p>
@@ -2096,17 +2301,17 @@
               <a:buNone/>
             </a:pPr>
             <a:r>
-              <a:rPr lang="en-US" sz="2700" b="1" dirty="0">
-                <a:solidFill>
-                  <a:srgbClr val="1B3A34"/>
+              <a:rPr lang="en-US" sz="2600" b="1" dirty="0">
+                <a:solidFill>
+                  <a:srgbClr val="1C3F60"/>
                 </a:solidFill>
                 <a:latin typeface="Georgia" pitchFamily="34" charset="0"/>
                 <a:ea typeface="Georgia" pitchFamily="34" charset="-122"/>
                 <a:cs typeface="Georgia" pitchFamily="34" charset="-120"/>
               </a:rPr>
-              <a:t>Three panes</a:t>
-            </a:r>
-            <a:endParaRPr lang="en-US" sz="2700" dirty="0"/>
+              <a:t>What separates them</a:t>
+            </a:r>
+            <a:endParaRPr lang="en-US" sz="2600" dirty="0"/>
           </a:p>
         </p:txBody>
       </p:sp>
@@ -2118,16 +2323,14 @@
         </p:nvSpPr>
         <p:spPr>
           <a:xfrm>
-            <a:off x="640080" y="2103120"/>
-            <a:ext cx="3383280" cy="2377440"/>
-          </a:xfrm>
-          <a:prstGeom prst="roundRect">
-            <a:avLst>
-              <a:gd name="adj" fmla="val 2308"/>
-            </a:avLst>
+            <a:off x="640080" y="2039112"/>
+            <a:ext cx="109728" cy="109728"/>
+          </a:xfrm>
+          <a:prstGeom prst="rect">
+            <a:avLst/>
           </a:prstGeom>
           <a:solidFill>
-            <a:srgbClr val="1B3A34"/>
+            <a:srgbClr val="D97E3F"/>
           </a:solidFill>
           <a:ln/>
         </p:spPr>
@@ -2140,47 +2343,8 @@
         </p:nvSpPr>
         <p:spPr>
           <a:xfrm>
-            <a:off x="914400" y="2331720"/>
-            <a:ext cx="2834640" cy="548640"/>
-          </a:xfrm>
-          <a:prstGeom prst="rect">
-            <a:avLst/>
-          </a:prstGeom>
-          <a:noFill/>
-          <a:ln/>
-        </p:spPr>
-        <p:txBody>
-          <a:bodyPr wrap="square" rtlCol="0" anchor="ctr"/>
-          <a:lstStyle/>
-          <a:p>
-            <a:pPr indent="0" marL="0">
-              <a:buNone/>
-            </a:pPr>
-            <a:r>
-              <a:rPr lang="en-US" sz="1900" b="1" dirty="0">
-                <a:solidFill>
-                  <a:srgbClr val="FFFFFF"/>
-                </a:solidFill>
-                <a:latin typeface="Georgia" pitchFamily="34" charset="0"/>
-                <a:ea typeface="Georgia" pitchFamily="34" charset="-122"/>
-                <a:cs typeface="Georgia" pitchFamily="34" charset="-120"/>
-              </a:rPr>
-              <a:t>Report</a:t>
-            </a:r>
-            <a:endParaRPr lang="en-US" sz="1900" dirty="0"/>
-          </a:p>
-        </p:txBody>
-      </p:sp>
-      <p:sp>
-        <p:nvSpPr>
-          <p:cNvPr id="6" name="Text 4"/>
-          <p:cNvSpPr/>
-          <p:nvPr/>
-        </p:nvSpPr>
-        <p:spPr>
-          <a:xfrm>
-            <a:off x="914400" y="2926080"/>
-            <a:ext cx="2834640" cy="1280160"/>
+            <a:off x="960120" y="1965960"/>
+            <a:ext cx="10241280" cy="548640"/>
           </a:xfrm>
           <a:prstGeom prst="rect">
             <a:avLst/>
@@ -2196,91 +2360,50 @@
               <a:buNone/>
             </a:pPr>
             <a:r>
-              <a:rPr lang="en-US" sz="1300" dirty="0">
-                <a:solidFill>
-                  <a:srgbClr val="D8E4E0"/>
+              <a:rPr lang="en-US" sz="1600" dirty="0">
+                <a:solidFill>
+                  <a:srgbClr val="2A2A2A"/>
                 </a:solidFill>
                 <a:latin typeface="Calibri" pitchFamily="34" charset="0"/>
                 <a:ea typeface="Calibri" pitchFamily="34" charset="-122"/>
                 <a:cs typeface="Calibri" pitchFamily="34" charset="-120"/>
               </a:rPr>
-              <a:t>what you're building</a:t>
-            </a:r>
-            <a:endParaRPr lang="en-US" sz="1300" dirty="0"/>
-          </a:p>
-        </p:txBody>
-      </p:sp>
-      <p:sp>
-        <p:nvSpPr>
-          <p:cNvPr id="7" name="Shape 5"/>
-          <p:cNvSpPr/>
-          <p:nvPr/>
-        </p:nvSpPr>
-        <p:spPr>
-          <a:xfrm>
-            <a:off x="4343400" y="2103120"/>
-            <a:ext cx="3383280" cy="2377440"/>
-          </a:xfrm>
-          <a:prstGeom prst="roundRect">
-            <a:avLst>
-              <a:gd name="adj" fmla="val 2308"/>
-            </a:avLst>
+              <a:t>The main point reads in five seconds, or the format is wrong.</a:t>
+            </a:r>
+            <a:endParaRPr lang="en-US" sz="1600" dirty="0"/>
+          </a:p>
+        </p:txBody>
+      </p:sp>
+      <p:sp>
+        <p:nvSpPr>
+          <p:cNvPr id="6" name="Shape 4"/>
+          <p:cNvSpPr/>
+          <p:nvPr/>
+        </p:nvSpPr>
+        <p:spPr>
+          <a:xfrm>
+            <a:off x="640080" y="2724912"/>
+            <a:ext cx="109728" cy="109728"/>
+          </a:xfrm>
+          <a:prstGeom prst="rect">
+            <a:avLst/>
           </a:prstGeom>
           <a:solidFill>
-            <a:srgbClr val="F4F1EC"/>
+            <a:srgbClr val="D97E3F"/>
           </a:solidFill>
           <a:ln/>
         </p:spPr>
       </p:sp>
       <p:sp>
         <p:nvSpPr>
-          <p:cNvPr id="8" name="Text 6"/>
-          <p:cNvSpPr/>
-          <p:nvPr/>
-        </p:nvSpPr>
-        <p:spPr>
-          <a:xfrm>
-            <a:off x="4617720" y="2331720"/>
-            <a:ext cx="2834640" cy="548640"/>
-          </a:xfrm>
-          <a:prstGeom prst="rect">
-            <a:avLst/>
-          </a:prstGeom>
-          <a:noFill/>
-          <a:ln/>
-        </p:spPr>
-        <p:txBody>
-          <a:bodyPr wrap="square" rtlCol="0" anchor="ctr"/>
-          <a:lstStyle/>
-          <a:p>
-            <a:pPr indent="0" marL="0">
-              <a:buNone/>
-            </a:pPr>
-            <a:r>
-              <a:rPr lang="en-US" sz="1900" b="1" dirty="0">
-                <a:solidFill>
-                  <a:srgbClr val="1B3A34"/>
-                </a:solidFill>
-                <a:latin typeface="Georgia" pitchFamily="34" charset="0"/>
-                <a:ea typeface="Georgia" pitchFamily="34" charset="-122"/>
-                <a:cs typeface="Georgia" pitchFamily="34" charset="-120"/>
-              </a:rPr>
-              <a:t>Data</a:t>
-            </a:r>
-            <a:endParaRPr lang="en-US" sz="1900" dirty="0"/>
-          </a:p>
-        </p:txBody>
-      </p:sp>
-      <p:sp>
-        <p:nvSpPr>
-          <p:cNvPr id="9" name="Text 7"/>
-          <p:cNvSpPr/>
-          <p:nvPr/>
-        </p:nvSpPr>
-        <p:spPr>
-          <a:xfrm>
-            <a:off x="4617720" y="2926080"/>
-            <a:ext cx="2834640" cy="1280160"/>
+          <p:cNvPr id="7" name="Text 5"/>
+          <p:cNvSpPr/>
+          <p:nvPr/>
+        </p:nvSpPr>
+        <p:spPr>
+          <a:xfrm>
+            <a:off x="960120" y="2651760"/>
+            <a:ext cx="10241280" cy="548640"/>
           </a:xfrm>
           <a:prstGeom prst="rect">
             <a:avLst/>
@@ -2296,7 +2419,7 @@
               <a:buNone/>
             </a:pPr>
             <a:r>
-              <a:rPr lang="en-US" sz="1300" dirty="0">
+              <a:rPr lang="en-US" sz="1600" dirty="0">
                 <a:solidFill>
                   <a:srgbClr val="2A2A2A"/>
                 </a:solidFill>
@@ -2304,83 +2427,42 @@
                 <a:ea typeface="Calibri" pitchFamily="34" charset="-122"/>
                 <a:cs typeface="Calibri" pitchFamily="34" charset="-120"/>
               </a:rPr>
-              <a:t>the table — same columns as last week</a:t>
-            </a:r>
-            <a:endParaRPr lang="en-US" sz="1300" dirty="0"/>
-          </a:p>
-        </p:txBody>
-      </p:sp>
-      <p:sp>
-        <p:nvSpPr>
-          <p:cNvPr id="10" name="Shape 8"/>
-          <p:cNvSpPr/>
-          <p:nvPr/>
-        </p:nvSpPr>
-        <p:spPr>
-          <a:xfrm>
-            <a:off x="8046720" y="2103120"/>
-            <a:ext cx="3383280" cy="2377440"/>
-          </a:xfrm>
-          <a:prstGeom prst="roundRect">
-            <a:avLst>
-              <a:gd name="adj" fmla="val 2308"/>
-            </a:avLst>
+              <a:t>5–9 key numbers on screen, not 20.</a:t>
+            </a:r>
+            <a:endParaRPr lang="en-US" sz="1600" dirty="0"/>
+          </a:p>
+        </p:txBody>
+      </p:sp>
+      <p:sp>
+        <p:nvSpPr>
+          <p:cNvPr id="8" name="Shape 6"/>
+          <p:cNvSpPr/>
+          <p:nvPr/>
+        </p:nvSpPr>
+        <p:spPr>
+          <a:xfrm>
+            <a:off x="640080" y="3410712"/>
+            <a:ext cx="109728" cy="109728"/>
+          </a:xfrm>
+          <a:prstGeom prst="rect">
+            <a:avLst/>
           </a:prstGeom>
           <a:solidFill>
-            <a:srgbClr val="F4F1EC"/>
+            <a:srgbClr val="D97E3F"/>
           </a:solidFill>
           <a:ln/>
         </p:spPr>
       </p:sp>
       <p:sp>
         <p:nvSpPr>
-          <p:cNvPr id="11" name="Text 9"/>
-          <p:cNvSpPr/>
-          <p:nvPr/>
-        </p:nvSpPr>
-        <p:spPr>
-          <a:xfrm>
-            <a:off x="8321040" y="2331720"/>
-            <a:ext cx="2834640" cy="548640"/>
-          </a:xfrm>
-          <a:prstGeom prst="rect">
-            <a:avLst/>
-          </a:prstGeom>
-          <a:noFill/>
-          <a:ln/>
-        </p:spPr>
-        <p:txBody>
-          <a:bodyPr wrap="square" rtlCol="0" anchor="ctr"/>
-          <a:lstStyle/>
-          <a:p>
-            <a:pPr indent="0" marL="0">
-              <a:buNone/>
-            </a:pPr>
-            <a:r>
-              <a:rPr lang="en-US" sz="1900" b="1" dirty="0">
-                <a:solidFill>
-                  <a:srgbClr val="1B3A34"/>
-                </a:solidFill>
-                <a:latin typeface="Georgia" pitchFamily="34" charset="0"/>
-                <a:ea typeface="Georgia" pitchFamily="34" charset="-122"/>
-                <a:cs typeface="Georgia" pitchFamily="34" charset="-120"/>
-              </a:rPr>
-              <a:t>Model</a:t>
-            </a:r>
-            <a:endParaRPr lang="en-US" sz="1900" dirty="0"/>
-          </a:p>
-        </p:txBody>
-      </p:sp>
-      <p:sp>
-        <p:nvSpPr>
-          <p:cNvPr id="12" name="Text 10"/>
-          <p:cNvSpPr/>
-          <p:nvPr/>
-        </p:nvSpPr>
-        <p:spPr>
-          <a:xfrm>
-            <a:off x="8321040" y="2926080"/>
-            <a:ext cx="2834640" cy="1280160"/>
+          <p:cNvPr id="9" name="Text 7"/>
+          <p:cNvSpPr/>
+          <p:nvPr/>
+        </p:nvSpPr>
+        <p:spPr>
+          <a:xfrm>
+            <a:off x="960120" y="3337560"/>
+            <a:ext cx="10241280" cy="548640"/>
           </a:xfrm>
           <a:prstGeom prst="rect">
             <a:avLst/>
@@ -2396,7 +2478,7 @@
               <a:buNone/>
             </a:pPr>
             <a:r>
-              <a:rPr lang="en-US" sz="1300" dirty="0">
+              <a:rPr lang="en-US" sz="1600" dirty="0">
                 <a:solidFill>
                   <a:srgbClr val="2A2A2A"/>
                 </a:solidFill>
@@ -2404,48 +2486,127 @@
                 <a:ea typeface="Calibri" pitchFamily="34" charset="-122"/>
                 <a:cs typeface="Calibri" pitchFamily="34" charset="-120"/>
               </a:rPr>
-              <a:t>relationships between tables — only one table today</a:t>
-            </a:r>
-            <a:endParaRPr lang="en-US" sz="1300" dirty="0"/>
-          </a:p>
-        </p:txBody>
-      </p:sp>
-      <p:sp>
-        <p:nvSpPr>
-          <p:cNvPr id="13" name="Text 11"/>
-          <p:cNvSpPr/>
-          <p:nvPr/>
-        </p:nvSpPr>
-        <p:spPr>
-          <a:xfrm>
-            <a:off x="640080" y="4846320"/>
-            <a:ext cx="10515600" cy="1005840"/>
-          </a:xfrm>
-          <a:prstGeom prst="rect">
-            <a:avLst/>
-          </a:prstGeom>
-          <a:noFill/>
-          <a:ln/>
-        </p:spPr>
-        <p:txBody>
-          <a:bodyPr wrap="square" rtlCol="0" anchor="ctr"/>
-          <a:lstStyle/>
-          <a:p>
-            <a:pPr indent="0" marL="0">
-              <a:buNone/>
-            </a:pPr>
-            <a:r>
-              <a:rPr lang="en-US" sz="1400" i="1" dirty="0">
-                <a:solidFill>
-                  <a:srgbClr val="6B6B6B"/>
+              <a:t>Every number has something to compare against — a target, a prior period.</a:t>
+            </a:r>
+            <a:endParaRPr lang="en-US" sz="1600" dirty="0"/>
+          </a:p>
+        </p:txBody>
+      </p:sp>
+      <p:sp>
+        <p:nvSpPr>
+          <p:cNvPr id="10" name="Shape 8"/>
+          <p:cNvSpPr/>
+          <p:nvPr/>
+        </p:nvSpPr>
+        <p:spPr>
+          <a:xfrm>
+            <a:off x="640080" y="4096512"/>
+            <a:ext cx="109728" cy="109728"/>
+          </a:xfrm>
+          <a:prstGeom prst="rect">
+            <a:avLst/>
+          </a:prstGeom>
+          <a:solidFill>
+            <a:srgbClr val="D97E3F"/>
+          </a:solidFill>
+          <a:ln/>
+        </p:spPr>
+      </p:sp>
+      <p:sp>
+        <p:nvSpPr>
+          <p:cNvPr id="11" name="Text 9"/>
+          <p:cNvSpPr/>
+          <p:nvPr/>
+        </p:nvSpPr>
+        <p:spPr>
+          <a:xfrm>
+            <a:off x="960120" y="4023360"/>
+            <a:ext cx="10241280" cy="548640"/>
+          </a:xfrm>
+          <a:prstGeom prst="rect">
+            <a:avLst/>
+          </a:prstGeom>
+          <a:noFill/>
+          <a:ln/>
+        </p:spPr>
+        <p:txBody>
+          <a:bodyPr wrap="square" rtlCol="0" anchor="t"/>
+          <a:lstStyle/>
+          <a:p>
+            <a:pPr indent="0" marL="0">
+              <a:buNone/>
+            </a:pPr>
+            <a:r>
+              <a:rPr lang="en-US" sz="1600" dirty="0">
+                <a:solidFill>
+                  <a:srgbClr val="2A2A2A"/>
                 </a:solidFill>
                 <a:latin typeface="Calibri" pitchFamily="34" charset="0"/>
                 <a:ea typeface="Calibri" pitchFamily="34" charset="-122"/>
                 <a:cs typeface="Calibri" pitchFamily="34" charset="-120"/>
               </a:rPr>
-              <a:t>First build, live: a bar chart of average Median salary by Major_category. Then a scatter of ShareWomen vs. Median — click a point and watch it filter everything else.</a:t>
-            </a:r>
-            <a:endParaRPr lang="en-US" sz="1400" dirty="0"/>
+              <a:t>The most important number: biggest, top-left.</a:t>
+            </a:r>
+            <a:endParaRPr lang="en-US" sz="1600" dirty="0"/>
+          </a:p>
+        </p:txBody>
+      </p:sp>
+      <p:sp>
+        <p:nvSpPr>
+          <p:cNvPr id="12" name="Shape 10"/>
+          <p:cNvSpPr/>
+          <p:nvPr/>
+        </p:nvSpPr>
+        <p:spPr>
+          <a:xfrm>
+            <a:off x="640080" y="4782312"/>
+            <a:ext cx="109728" cy="109728"/>
+          </a:xfrm>
+          <a:prstGeom prst="rect">
+            <a:avLst/>
+          </a:prstGeom>
+          <a:solidFill>
+            <a:srgbClr val="D97E3F"/>
+          </a:solidFill>
+          <a:ln/>
+        </p:spPr>
+      </p:sp>
+      <p:sp>
+        <p:nvSpPr>
+          <p:cNvPr id="13" name="Text 11"/>
+          <p:cNvSpPr/>
+          <p:nvPr/>
+        </p:nvSpPr>
+        <p:spPr>
+          <a:xfrm>
+            <a:off x="960120" y="4709160"/>
+            <a:ext cx="10241280" cy="548640"/>
+          </a:xfrm>
+          <a:prstGeom prst="rect">
+            <a:avLst/>
+          </a:prstGeom>
+          <a:noFill/>
+          <a:ln/>
+        </p:spPr>
+        <p:txBody>
+          <a:bodyPr wrap="square" rtlCol="0" anchor="t"/>
+          <a:lstStyle/>
+          <a:p>
+            <a:pPr indent="0" marL="0">
+              <a:buNone/>
+            </a:pPr>
+            <a:r>
+              <a:rPr lang="en-US" sz="1600" dirty="0">
+                <a:solidFill>
+                  <a:srgbClr val="2A2A2A"/>
+                </a:solidFill>
+                <a:latin typeface="Calibri" pitchFamily="34" charset="0"/>
+                <a:ea typeface="Calibri" pitchFamily="34" charset="-122"/>
+                <a:cs typeface="Calibri" pitchFamily="34" charset="-120"/>
+              </a:rPr>
+              <a:t>No 3D charts. Simplest chart that makes the point wins.</a:t>
+            </a:r>
+            <a:endParaRPr lang="en-US" sz="1600" dirty="0"/>
           </a:p>
         </p:txBody>
       </p:sp>
@@ -2514,7 +2675,7 @@
                 <a:ea typeface="Calibri" pitchFamily="34" charset="-122"/>
                 <a:cs typeface="Calibri" pitchFamily="34" charset="-120"/>
               </a:rPr>
-              <a:t>GUIDED BUILD — 25 MIN</a:t>
+              <a:t>BEFORE YOU BUILD</a:t>
             </a:r>
             <a:endParaRPr lang="en-US" sz="1200" dirty="0"/>
           </a:p>
@@ -2545,17 +2706,17 @@
               <a:buNone/>
             </a:pPr>
             <a:r>
-              <a:rPr lang="en-US" sz="2700" b="1" dirty="0">
-                <a:solidFill>
-                  <a:srgbClr val="1B3A34"/>
+              <a:rPr lang="en-US" sz="2600" b="1" dirty="0">
+                <a:solidFill>
+                  <a:srgbClr val="1C3F60"/>
                 </a:solidFill>
                 <a:latin typeface="Georgia" pitchFamily="34" charset="0"/>
                 <a:ea typeface="Georgia" pitchFamily="34" charset="-122"/>
                 <a:cs typeface="Georgia" pitchFamily="34" charset="-120"/>
               </a:rPr>
-              <a:t>Rebuild, then add a third visual</a:t>
-            </a:r>
-            <a:endParaRPr lang="en-US" sz="2700" dirty="0"/>
+              <a:t>Look at what good already looks like</a:t>
+            </a:r>
+            <a:endParaRPr lang="en-US" sz="2600" dirty="0"/>
           </a:p>
         </p:txBody>
       </p:sp>
@@ -2567,14 +2728,14 @@
         </p:nvSpPr>
         <p:spPr>
           <a:xfrm>
-            <a:off x="640080" y="2148840"/>
-            <a:ext cx="365760" cy="365760"/>
-          </a:xfrm>
-          <a:prstGeom prst="ellipse">
+            <a:off x="640080" y="2103120"/>
+            <a:ext cx="5257800" cy="2651760"/>
+          </a:xfrm>
+          <a:prstGeom prst="rect">
             <a:avLst/>
           </a:prstGeom>
           <a:solidFill>
-            <a:srgbClr val="5B8A82"/>
+            <a:srgbClr val="F4F1EC"/>
           </a:solidFill>
           <a:ln/>
         </p:spPr>
@@ -2587,8 +2748,8 @@
         </p:nvSpPr>
         <p:spPr>
           <a:xfrm>
-            <a:off x="640080" y="2148840"/>
-            <a:ext cx="365760" cy="365760"/>
+            <a:off x="914400" y="2377440"/>
+            <a:ext cx="4709160" cy="457200"/>
           </a:xfrm>
           <a:prstGeom prst="rect">
             <a:avLst/>
@@ -2600,34 +2761,132 @@
           <a:bodyPr wrap="square" rtlCol="0" anchor="ctr"/>
           <a:lstStyle/>
           <a:p>
-            <a:pPr algn="ctr" indent="0" marL="0">
-              <a:buNone/>
-            </a:pPr>
-            <a:r>
-              <a:rPr lang="en-US" sz="1400" b="1" dirty="0">
-                <a:solidFill>
-                  <a:srgbClr val="FFFFFF"/>
+            <a:pPr indent="0" marL="0">
+              <a:buNone/>
+            </a:pPr>
+            <a:r>
+              <a:rPr lang="en-US" sz="1800" b="1" dirty="0">
+                <a:solidFill>
+                  <a:srgbClr val="1C3F60"/>
+                </a:solidFill>
+                <a:latin typeface="Georgia" pitchFamily="34" charset="0"/>
+                <a:ea typeface="Georgia" pitchFamily="34" charset="-122"/>
+                <a:cs typeface="Georgia" pitchFamily="34" charset="-120"/>
+              </a:rPr>
+              <a:t>Tableau Public Gallery</a:t>
+            </a:r>
+            <a:endParaRPr lang="en-US" sz="1800" dirty="0"/>
+          </a:p>
+        </p:txBody>
+      </p:sp>
+      <p:sp>
+        <p:nvSpPr>
+          <p:cNvPr id="6" name="Text 4"/>
+          <p:cNvSpPr/>
+          <p:nvPr/>
+        </p:nvSpPr>
+        <p:spPr>
+          <a:xfrm>
+            <a:off x="914400" y="2880360"/>
+            <a:ext cx="4709160" cy="365760"/>
+          </a:xfrm>
+          <a:prstGeom prst="rect">
+            <a:avLst/>
+          </a:prstGeom>
+          <a:noFill/>
+          <a:ln/>
+        </p:spPr>
+        <p:txBody>
+          <a:bodyPr wrap="square" rtlCol="0" anchor="ctr"/>
+          <a:lstStyle/>
+          <a:p>
+            <a:pPr indent="0" marL="0">
+              <a:buNone/>
+            </a:pPr>
+            <a:r>
+              <a:rPr lang="en-US" sz="1300" dirty="0">
+                <a:solidFill>
+                  <a:srgbClr val="D97E3F"/>
+                </a:solidFill>
+                <a:latin typeface="Courier New" pitchFamily="34" charset="0"/>
+                <a:ea typeface="Courier New" pitchFamily="34" charset="-122"/>
+                <a:cs typeface="Courier New" pitchFamily="34" charset="-120"/>
+              </a:rPr>
+              <a:t>public.tableau.com/app</a:t>
+            </a:r>
+            <a:endParaRPr lang="en-US" sz="1300" dirty="0"/>
+          </a:p>
+        </p:txBody>
+      </p:sp>
+      <p:sp>
+        <p:nvSpPr>
+          <p:cNvPr id="7" name="Text 5"/>
+          <p:cNvSpPr/>
+          <p:nvPr/>
+        </p:nvSpPr>
+        <p:spPr>
+          <a:xfrm>
+            <a:off x="914400" y="3383280"/>
+            <a:ext cx="4709160" cy="1097280"/>
+          </a:xfrm>
+          <a:prstGeom prst="rect">
+            <a:avLst/>
+          </a:prstGeom>
+          <a:noFill/>
+          <a:ln/>
+        </p:spPr>
+        <p:txBody>
+          <a:bodyPr wrap="square" rtlCol="0" anchor="t"/>
+          <a:lstStyle/>
+          <a:p>
+            <a:pPr indent="0" marL="0">
+              <a:buNone/>
+            </a:pPr>
+            <a:r>
+              <a:rPr lang="en-US" sz="1300" dirty="0">
+                <a:solidFill>
+                  <a:srgbClr val="2A2A2A"/>
                 </a:solidFill>
                 <a:latin typeface="Calibri" pitchFamily="34" charset="0"/>
                 <a:ea typeface="Calibri" pitchFamily="34" charset="-122"/>
                 <a:cs typeface="Calibri" pitchFamily="34" charset="-120"/>
               </a:rPr>
-              <a:t>1</a:t>
-            </a:r>
-            <a:endParaRPr lang="en-US" sz="1400" dirty="0"/>
-          </a:p>
-        </p:txBody>
-      </p:sp>
-      <p:sp>
-        <p:nvSpPr>
-          <p:cNvPr id="6" name="Text 4"/>
-          <p:cNvSpPr/>
-          <p:nvPr/>
-        </p:nvSpPr>
-        <p:spPr>
-          <a:xfrm>
-            <a:off x="1188720" y="2103120"/>
-            <a:ext cx="9875520" cy="502920"/>
+              <a:t>Browse by topic, sorted by what's currently featured.</a:t>
+            </a:r>
+            <a:endParaRPr lang="en-US" sz="1300" dirty="0"/>
+          </a:p>
+        </p:txBody>
+      </p:sp>
+      <p:sp>
+        <p:nvSpPr>
+          <p:cNvPr id="8" name="Shape 6"/>
+          <p:cNvSpPr/>
+          <p:nvPr/>
+        </p:nvSpPr>
+        <p:spPr>
+          <a:xfrm>
+            <a:off x="6263640" y="2103120"/>
+            <a:ext cx="5257800" cy="2651760"/>
+          </a:xfrm>
+          <a:prstGeom prst="rect">
+            <a:avLst/>
+          </a:prstGeom>
+          <a:solidFill>
+            <a:srgbClr val="F4F1EC"/>
+          </a:solidFill>
+          <a:ln/>
+        </p:spPr>
+      </p:sp>
+      <p:sp>
+        <p:nvSpPr>
+          <p:cNvPr id="9" name="Text 7"/>
+          <p:cNvSpPr/>
+          <p:nvPr/>
+        </p:nvSpPr>
+        <p:spPr>
+          <a:xfrm>
+            <a:off x="6537960" y="2377440"/>
+            <a:ext cx="4709160" cy="457200"/>
           </a:xfrm>
           <a:prstGeom prst="rect">
             <a:avLst/>
@@ -2643,7 +2902,85 @@
               <a:buNone/>
             </a:pPr>
             <a:r>
-              <a:rPr lang="en-US" sz="1600" dirty="0">
+              <a:rPr lang="en-US" sz="1800" b="1" dirty="0">
+                <a:solidFill>
+                  <a:srgbClr val="1C3F60"/>
+                </a:solidFill>
+                <a:latin typeface="Georgia" pitchFamily="34" charset="0"/>
+                <a:ea typeface="Georgia" pitchFamily="34" charset="-122"/>
+                <a:cs typeface="Georgia" pitchFamily="34" charset="-120"/>
+              </a:rPr>
+              <a:t>Makeover Monday</a:t>
+            </a:r>
+            <a:endParaRPr lang="en-US" sz="1800" dirty="0"/>
+          </a:p>
+        </p:txBody>
+      </p:sp>
+      <p:sp>
+        <p:nvSpPr>
+          <p:cNvPr id="10" name="Text 8"/>
+          <p:cNvSpPr/>
+          <p:nvPr/>
+        </p:nvSpPr>
+        <p:spPr>
+          <a:xfrm>
+            <a:off x="6537960" y="2880360"/>
+            <a:ext cx="4709160" cy="365760"/>
+          </a:xfrm>
+          <a:prstGeom prst="rect">
+            <a:avLst/>
+          </a:prstGeom>
+          <a:noFill/>
+          <a:ln/>
+        </p:spPr>
+        <p:txBody>
+          <a:bodyPr wrap="square" rtlCol="0" anchor="ctr"/>
+          <a:lstStyle/>
+          <a:p>
+            <a:pPr indent="0" marL="0">
+              <a:buNone/>
+            </a:pPr>
+            <a:r>
+              <a:rPr lang="en-US" sz="1300" dirty="0">
+                <a:solidFill>
+                  <a:srgbClr val="D97E3F"/>
+                </a:solidFill>
+                <a:latin typeface="Courier New" pitchFamily="34" charset="0"/>
+                <a:ea typeface="Courier New" pitchFamily="34" charset="-122"/>
+                <a:cs typeface="Courier New" pitchFamily="34" charset="-120"/>
+              </a:rPr>
+              <a:t>makeovermonday.co.uk</a:t>
+            </a:r>
+            <a:endParaRPr lang="en-US" sz="1300" dirty="0"/>
+          </a:p>
+        </p:txBody>
+      </p:sp>
+      <p:sp>
+        <p:nvSpPr>
+          <p:cNvPr id="11" name="Text 9"/>
+          <p:cNvSpPr/>
+          <p:nvPr/>
+        </p:nvSpPr>
+        <p:spPr>
+          <a:xfrm>
+            <a:off x="6537960" y="3383280"/>
+            <a:ext cx="4709160" cy="1280160"/>
+          </a:xfrm>
+          <a:prstGeom prst="rect">
+            <a:avLst/>
+          </a:prstGeom>
+          <a:noFill/>
+          <a:ln/>
+        </p:spPr>
+        <p:txBody>
+          <a:bodyPr wrap="square" rtlCol="0" anchor="t"/>
+          <a:lstStyle/>
+          <a:p>
+            <a:pPr indent="0" marL="0">
+              <a:buNone/>
+            </a:pPr>
+            <a:r>
+              <a:rPr lang="en-US" sz="1300" dirty="0">
                 <a:solidFill>
                   <a:srgbClr val="2A2A2A"/>
                 </a:solidFill>
@@ -2651,342 +2988,9 @@
                 <a:ea typeface="Calibri" pitchFamily="34" charset="-122"/>
                 <a:cs typeface="Calibri" pitchFamily="34" charset="-120"/>
               </a:rPr>
-              <a:t>Bar chart: average Median salary by Major_category</a:t>
-            </a:r>
-            <a:endParaRPr lang="en-US" sz="1600" dirty="0"/>
-          </a:p>
-        </p:txBody>
-      </p:sp>
-      <p:sp>
-        <p:nvSpPr>
-          <p:cNvPr id="7" name="Shape 5"/>
-          <p:cNvSpPr/>
-          <p:nvPr/>
-        </p:nvSpPr>
-        <p:spPr>
-          <a:xfrm>
-            <a:off x="640080" y="2926080"/>
-            <a:ext cx="365760" cy="365760"/>
-          </a:xfrm>
-          <a:prstGeom prst="ellipse">
-            <a:avLst/>
-          </a:prstGeom>
-          <a:solidFill>
-            <a:srgbClr val="5B8A82"/>
-          </a:solidFill>
-          <a:ln/>
-        </p:spPr>
-      </p:sp>
-      <p:sp>
-        <p:nvSpPr>
-          <p:cNvPr id="8" name="Text 6"/>
-          <p:cNvSpPr/>
-          <p:nvPr/>
-        </p:nvSpPr>
-        <p:spPr>
-          <a:xfrm>
-            <a:off x="640080" y="2926080"/>
-            <a:ext cx="365760" cy="365760"/>
-          </a:xfrm>
-          <a:prstGeom prst="rect">
-            <a:avLst/>
-          </a:prstGeom>
-          <a:noFill/>
-          <a:ln/>
-        </p:spPr>
-        <p:txBody>
-          <a:bodyPr wrap="square" rtlCol="0" anchor="ctr"/>
-          <a:lstStyle/>
-          <a:p>
-            <a:pPr algn="ctr" indent="0" marL="0">
-              <a:buNone/>
-            </a:pPr>
-            <a:r>
-              <a:rPr lang="en-US" sz="1400" b="1" dirty="0">
-                <a:solidFill>
-                  <a:srgbClr val="FFFFFF"/>
-                </a:solidFill>
-                <a:latin typeface="Calibri" pitchFamily="34" charset="0"/>
-                <a:ea typeface="Calibri" pitchFamily="34" charset="-122"/>
-                <a:cs typeface="Calibri" pitchFamily="34" charset="-120"/>
-              </a:rPr>
-              <a:t>2</a:t>
-            </a:r>
-            <a:endParaRPr lang="en-US" sz="1400" dirty="0"/>
-          </a:p>
-        </p:txBody>
-      </p:sp>
-      <p:sp>
-        <p:nvSpPr>
-          <p:cNvPr id="9" name="Text 7"/>
-          <p:cNvSpPr/>
-          <p:nvPr/>
-        </p:nvSpPr>
-        <p:spPr>
-          <a:xfrm>
-            <a:off x="1188720" y="2880360"/>
-            <a:ext cx="9875520" cy="502920"/>
-          </a:xfrm>
-          <a:prstGeom prst="rect">
-            <a:avLst/>
-          </a:prstGeom>
-          <a:noFill/>
-          <a:ln/>
-        </p:spPr>
-        <p:txBody>
-          <a:bodyPr wrap="square" rtlCol="0" anchor="ctr"/>
-          <a:lstStyle/>
-          <a:p>
-            <a:pPr indent="0" marL="0">
-              <a:buNone/>
-            </a:pPr>
-            <a:r>
-              <a:rPr lang="en-US" sz="1600" dirty="0">
-                <a:solidFill>
-                  <a:srgbClr val="2A2A2A"/>
-                </a:solidFill>
-                <a:latin typeface="Calibri" pitchFamily="34" charset="0"/>
-                <a:ea typeface="Calibri" pitchFamily="34" charset="-122"/>
-                <a:cs typeface="Calibri" pitchFamily="34" charset="-120"/>
-              </a:rPr>
-              <a:t>Scatter plot: ShareWomen (x) vs. Median (y)</a:t>
-            </a:r>
-            <a:endParaRPr lang="en-US" sz="1600" dirty="0"/>
-          </a:p>
-        </p:txBody>
-      </p:sp>
-      <p:sp>
-        <p:nvSpPr>
-          <p:cNvPr id="10" name="Shape 8"/>
-          <p:cNvSpPr/>
-          <p:nvPr/>
-        </p:nvSpPr>
-        <p:spPr>
-          <a:xfrm>
-            <a:off x="640080" y="3703320"/>
-            <a:ext cx="365760" cy="365760"/>
-          </a:xfrm>
-          <a:prstGeom prst="ellipse">
-            <a:avLst/>
-          </a:prstGeom>
-          <a:solidFill>
-            <a:srgbClr val="5B8A82"/>
-          </a:solidFill>
-          <a:ln/>
-        </p:spPr>
-      </p:sp>
-      <p:sp>
-        <p:nvSpPr>
-          <p:cNvPr id="11" name="Text 9"/>
-          <p:cNvSpPr/>
-          <p:nvPr/>
-        </p:nvSpPr>
-        <p:spPr>
-          <a:xfrm>
-            <a:off x="640080" y="3703320"/>
-            <a:ext cx="365760" cy="365760"/>
-          </a:xfrm>
-          <a:prstGeom prst="rect">
-            <a:avLst/>
-          </a:prstGeom>
-          <a:noFill/>
-          <a:ln/>
-        </p:spPr>
-        <p:txBody>
-          <a:bodyPr wrap="square" rtlCol="0" anchor="ctr"/>
-          <a:lstStyle/>
-          <a:p>
-            <a:pPr algn="ctr" indent="0" marL="0">
-              <a:buNone/>
-            </a:pPr>
-            <a:r>
-              <a:rPr lang="en-US" sz="1400" b="1" dirty="0">
-                <a:solidFill>
-                  <a:srgbClr val="FFFFFF"/>
-                </a:solidFill>
-                <a:latin typeface="Calibri" pitchFamily="34" charset="0"/>
-                <a:ea typeface="Calibri" pitchFamily="34" charset="-122"/>
-                <a:cs typeface="Calibri" pitchFamily="34" charset="-120"/>
-              </a:rPr>
-              <a:t>3</a:t>
-            </a:r>
-            <a:endParaRPr lang="en-US" sz="1400" dirty="0"/>
-          </a:p>
-        </p:txBody>
-      </p:sp>
-      <p:sp>
-        <p:nvSpPr>
-          <p:cNvPr id="12" name="Text 10"/>
-          <p:cNvSpPr/>
-          <p:nvPr/>
-        </p:nvSpPr>
-        <p:spPr>
-          <a:xfrm>
-            <a:off x="1188720" y="3657600"/>
-            <a:ext cx="9875520" cy="502920"/>
-          </a:xfrm>
-          <a:prstGeom prst="rect">
-            <a:avLst/>
-          </a:prstGeom>
-          <a:noFill/>
-          <a:ln/>
-        </p:spPr>
-        <p:txBody>
-          <a:bodyPr wrap="square" rtlCol="0" anchor="ctr"/>
-          <a:lstStyle/>
-          <a:p>
-            <a:pPr indent="0" marL="0">
-              <a:buNone/>
-            </a:pPr>
-            <a:r>
-              <a:rPr lang="en-US" sz="1600" dirty="0">
-                <a:solidFill>
-                  <a:srgbClr val="2A2A2A"/>
-                </a:solidFill>
-                <a:latin typeface="Calibri" pitchFamily="34" charset="0"/>
-                <a:ea typeface="Calibri" pitchFamily="34" charset="-122"/>
-                <a:cs typeface="Calibri" pitchFamily="34" charset="-120"/>
-              </a:rPr>
-              <a:t>Slicer on Major_category — filter the whole dashboard at once</a:t>
-            </a:r>
-            <a:endParaRPr lang="en-US" sz="1600" dirty="0"/>
-          </a:p>
-        </p:txBody>
-      </p:sp>
-      <p:sp>
-        <p:nvSpPr>
-          <p:cNvPr id="13" name="Shape 11"/>
-          <p:cNvSpPr/>
-          <p:nvPr/>
-        </p:nvSpPr>
-        <p:spPr>
-          <a:xfrm>
-            <a:off x="640080" y="4480560"/>
-            <a:ext cx="365760" cy="365760"/>
-          </a:xfrm>
-          <a:prstGeom prst="ellipse">
-            <a:avLst/>
-          </a:prstGeom>
-          <a:solidFill>
-            <a:srgbClr val="D97E3F"/>
-          </a:solidFill>
-          <a:ln/>
-        </p:spPr>
-      </p:sp>
-      <p:sp>
-        <p:nvSpPr>
-          <p:cNvPr id="14" name="Text 12"/>
-          <p:cNvSpPr/>
-          <p:nvPr/>
-        </p:nvSpPr>
-        <p:spPr>
-          <a:xfrm>
-            <a:off x="640080" y="4480560"/>
-            <a:ext cx="365760" cy="365760"/>
-          </a:xfrm>
-          <a:prstGeom prst="rect">
-            <a:avLst/>
-          </a:prstGeom>
-          <a:noFill/>
-          <a:ln/>
-        </p:spPr>
-        <p:txBody>
-          <a:bodyPr wrap="square" rtlCol="0" anchor="ctr"/>
-          <a:lstStyle/>
-          <a:p>
-            <a:pPr algn="ctr" indent="0" marL="0">
-              <a:buNone/>
-            </a:pPr>
-            <a:r>
-              <a:rPr lang="en-US" sz="1400" b="1" dirty="0">
-                <a:solidFill>
-                  <a:srgbClr val="FFFFFF"/>
-                </a:solidFill>
-                <a:latin typeface="Calibri" pitchFamily="34" charset="0"/>
-                <a:ea typeface="Calibri" pitchFamily="34" charset="-122"/>
-                <a:cs typeface="Calibri" pitchFamily="34" charset="-120"/>
-              </a:rPr>
-              <a:t>4</a:t>
-            </a:r>
-            <a:endParaRPr lang="en-US" sz="1400" dirty="0"/>
-          </a:p>
-        </p:txBody>
-      </p:sp>
-      <p:sp>
-        <p:nvSpPr>
-          <p:cNvPr id="15" name="Text 13"/>
-          <p:cNvSpPr/>
-          <p:nvPr/>
-        </p:nvSpPr>
-        <p:spPr>
-          <a:xfrm>
-            <a:off x="1188720" y="4434840"/>
-            <a:ext cx="9875520" cy="502920"/>
-          </a:xfrm>
-          <a:prstGeom prst="rect">
-            <a:avLst/>
-          </a:prstGeom>
-          <a:noFill/>
-          <a:ln/>
-        </p:spPr>
-        <p:txBody>
-          <a:bodyPr wrap="square" rtlCol="0" anchor="ctr"/>
-          <a:lstStyle/>
-          <a:p>
-            <a:pPr indent="0" marL="0">
-              <a:buNone/>
-            </a:pPr>
-            <a:r>
-              <a:rPr lang="en-US" sz="1600" dirty="0">
-                <a:solidFill>
-                  <a:srgbClr val="2A2A2A"/>
-                </a:solidFill>
-                <a:latin typeface="Calibri" pitchFamily="34" charset="0"/>
-                <a:ea typeface="Calibri" pitchFamily="34" charset="-122"/>
-                <a:cs typeface="Calibri" pitchFamily="34" charset="-120"/>
-              </a:rPr>
-              <a:t>Your choice: a third visual, ideally reusing your Week 2 engineered column</a:t>
-            </a:r>
-            <a:endParaRPr lang="en-US" sz="1600" dirty="0"/>
-          </a:p>
-        </p:txBody>
-      </p:sp>
-      <p:sp>
-        <p:nvSpPr>
-          <p:cNvPr id="16" name="Text 14"/>
-          <p:cNvSpPr/>
-          <p:nvPr/>
-        </p:nvSpPr>
-        <p:spPr>
-          <a:xfrm>
-            <a:off x="640080" y="5394960"/>
-            <a:ext cx="10058400" cy="457200"/>
-          </a:xfrm>
-          <a:prstGeom prst="rect">
-            <a:avLst/>
-          </a:prstGeom>
-          <a:noFill/>
-          <a:ln/>
-        </p:spPr>
-        <p:txBody>
-          <a:bodyPr wrap="square" rtlCol="0" anchor="ctr"/>
-          <a:lstStyle/>
-          <a:p>
-            <a:pPr indent="0" marL="0">
-              <a:buNone/>
-            </a:pPr>
-            <a:r>
-              <a:rPr lang="en-US" sz="1400" b="1" i="1" dirty="0">
-                <a:solidFill>
-                  <a:srgbClr val="1B3A34"/>
-                </a:solidFill>
-                <a:latin typeface="Calibri" pitchFamily="34" charset="0"/>
-                <a:ea typeface="Calibri" pitchFamily="34" charset="-122"/>
-                <a:cs typeface="Calibri" pitchFamily="34" charset="-120"/>
-              </a:rPr>
-              <a:t>“A chart only you can interpret isn't a finding yet — it's a draft.”</a:t>
-            </a:r>
-            <a:endParaRPr lang="en-US" sz="1400" dirty="0"/>
+              <a:t>A weekly project where people rebuild the same chart better. Five takes on one dataset makes “good vs. busy” concrete.</a:t>
+            </a:r>
+            <a:endParaRPr lang="en-US" sz="1300" dirty="0"/>
           </a:p>
         </p:txBody>
       </p:sp>
@@ -3055,7 +3059,7 @@
                 <a:ea typeface="Calibri" pitchFamily="34" charset="-122"/>
                 <a:cs typeface="Calibri" pitchFamily="34" charset="-120"/>
               </a:rPr>
-              <a:t>DASHBOARDS FOR A REAL AUDIENCE</a:t>
+              <a:t>ORIENTATION</a:t>
             </a:r>
             <a:endParaRPr lang="en-US" sz="1200" dirty="0"/>
           </a:p>
@@ -3086,17 +3090,17 @@
               <a:buNone/>
             </a:pPr>
             <a:r>
-              <a:rPr lang="en-US" sz="2700" b="1" dirty="0">
-                <a:solidFill>
-                  <a:srgbClr val="1B3A34"/>
+              <a:rPr lang="en-US" sz="2600" b="1" dirty="0">
+                <a:solidFill>
+                  <a:srgbClr val="1C3F60"/>
                 </a:solidFill>
                 <a:latin typeface="Georgia" pitchFamily="34" charset="0"/>
                 <a:ea typeface="Georgia" pitchFamily="34" charset="-122"/>
                 <a:cs typeface="Georgia" pitchFamily="34" charset="-120"/>
               </a:rPr>
-              <a:t>The five-second test</a:t>
-            </a:r>
-            <a:endParaRPr lang="en-US" sz="2700" dirty="0"/>
+              <a:t>Data pane, shelves, marks</a:t>
+            </a:r>
+            <a:endParaRPr lang="en-US" sz="2600" dirty="0"/>
           </a:p>
         </p:txBody>
       </p:sp>
@@ -3109,15 +3113,13 @@
         <p:spPr>
           <a:xfrm>
             <a:off x="640080" y="2011680"/>
-            <a:ext cx="10881360" cy="1188720"/>
-          </a:xfrm>
-          <a:prstGeom prst="roundRect">
-            <a:avLst>
-              <a:gd name="adj" fmla="val 4615"/>
-            </a:avLst>
+            <a:ext cx="3383280" cy="2377440"/>
+          </a:xfrm>
+          <a:prstGeom prst="rect">
+            <a:avLst/>
           </a:prstGeom>
           <a:solidFill>
-            <a:srgbClr val="1B3A34"/>
+            <a:srgbClr val="1C3F60"/>
           </a:solidFill>
           <a:ln/>
         </p:spPr>
@@ -3130,8 +3132,8 @@
         </p:nvSpPr>
         <p:spPr>
           <a:xfrm>
-            <a:off x="1005840" y="2011680"/>
-            <a:ext cx="10149840" cy="1188720"/>
+            <a:off x="914400" y="2240280"/>
+            <a:ext cx="2834640" cy="548640"/>
           </a:xfrm>
           <a:prstGeom prst="rect">
             <a:avLst/>
@@ -3143,19 +3145,117 @@
           <a:bodyPr wrap="square" rtlCol="0" anchor="ctr"/>
           <a:lstStyle/>
           <a:p>
-            <a:pPr algn="ctr" indent="0" marL="0">
+            <a:pPr indent="0" marL="0">
               <a:buNone/>
             </a:pPr>
             <a:r>
               <a:rPr lang="en-US" sz="1700" b="1" dirty="0">
                 <a:solidFill>
                   <a:srgbClr val="FFFFFF"/>
+                </a:solidFill>
+                <a:latin typeface="Georgia" pitchFamily="34" charset="0"/>
+                <a:ea typeface="Georgia" pitchFamily="34" charset="-122"/>
+                <a:cs typeface="Georgia" pitchFamily="34" charset="-120"/>
+              </a:rPr>
+              <a:t>Data pane</a:t>
+            </a:r>
+            <a:endParaRPr lang="en-US" sz="1700" dirty="0"/>
+          </a:p>
+        </p:txBody>
+      </p:sp>
+      <p:sp>
+        <p:nvSpPr>
+          <p:cNvPr id="6" name="Text 4"/>
+          <p:cNvSpPr/>
+          <p:nvPr/>
+        </p:nvSpPr>
+        <p:spPr>
+          <a:xfrm>
+            <a:off x="914400" y="2834640"/>
+            <a:ext cx="2834640" cy="1371600"/>
+          </a:xfrm>
+          <a:prstGeom prst="rect">
+            <a:avLst/>
+          </a:prstGeom>
+          <a:noFill/>
+          <a:ln/>
+        </p:spPr>
+        <p:txBody>
+          <a:bodyPr wrap="square" rtlCol="0" anchor="t"/>
+          <a:lstStyle/>
+          <a:p>
+            <a:pPr indent="0" marL="0">
+              <a:buNone/>
+            </a:pPr>
+            <a:r>
+              <a:rPr lang="en-US" sz="1250" dirty="0">
+                <a:solidFill>
+                  <a:srgbClr val="D6E2EA"/>
                 </a:solidFill>
                 <a:latin typeface="Calibri" pitchFamily="34" charset="0"/>
                 <a:ea typeface="Calibri" pitchFamily="34" charset="-122"/>
                 <a:cs typeface="Calibri" pitchFamily="34" charset="-120"/>
               </a:rPr>
-              <a:t>“If you had never seen this dataset, what would you understand from this screen in the first five seconds?”</a:t>
+              <a:t>Dimensions (blue) on top, Measures (green) below</a:t>
+            </a:r>
+            <a:endParaRPr lang="en-US" sz="1250" dirty="0"/>
+          </a:p>
+        </p:txBody>
+      </p:sp>
+      <p:sp>
+        <p:nvSpPr>
+          <p:cNvPr id="7" name="Shape 5"/>
+          <p:cNvSpPr/>
+          <p:nvPr/>
+        </p:nvSpPr>
+        <p:spPr>
+          <a:xfrm>
+            <a:off x="4343400" y="2011680"/>
+            <a:ext cx="3383280" cy="2377440"/>
+          </a:xfrm>
+          <a:prstGeom prst="rect">
+            <a:avLst/>
+          </a:prstGeom>
+          <a:solidFill>
+            <a:srgbClr val="F4F1EC"/>
+          </a:solidFill>
+          <a:ln/>
+        </p:spPr>
+      </p:sp>
+      <p:sp>
+        <p:nvSpPr>
+          <p:cNvPr id="8" name="Text 6"/>
+          <p:cNvSpPr/>
+          <p:nvPr/>
+        </p:nvSpPr>
+        <p:spPr>
+          <a:xfrm>
+            <a:off x="4617720" y="2240280"/>
+            <a:ext cx="2834640" cy="548640"/>
+          </a:xfrm>
+          <a:prstGeom prst="rect">
+            <a:avLst/>
+          </a:prstGeom>
+          <a:noFill/>
+          <a:ln/>
+        </p:spPr>
+        <p:txBody>
+          <a:bodyPr wrap="square" rtlCol="0" anchor="ctr"/>
+          <a:lstStyle/>
+          <a:p>
+            <a:pPr indent="0" marL="0">
+              <a:buNone/>
+            </a:pPr>
+            <a:r>
+              <a:rPr lang="en-US" sz="1700" b="1" dirty="0">
+                <a:solidFill>
+                  <a:srgbClr val="1C3F60"/>
+                </a:solidFill>
+                <a:latin typeface="Georgia" pitchFamily="34" charset="0"/>
+                <a:ea typeface="Georgia" pitchFamily="34" charset="-122"/>
+                <a:cs typeface="Georgia" pitchFamily="34" charset="-120"/>
+              </a:rPr>
+              <a:t>Rows / Columns</a:t>
             </a:r>
             <a:endParaRPr lang="en-US" sz="1700" dirty="0"/>
           </a:p>
@@ -3163,53 +3263,73 @@
       </p:sp>
       <p:sp>
         <p:nvSpPr>
-          <p:cNvPr id="6" name="Text 4"/>
-          <p:cNvSpPr/>
-          <p:nvPr/>
-        </p:nvSpPr>
-        <p:spPr>
-          <a:xfrm>
-            <a:off x="640080" y="3520440"/>
-            <a:ext cx="9144000" cy="365760"/>
-          </a:xfrm>
-          <a:prstGeom prst="rect">
-            <a:avLst/>
-          </a:prstGeom>
-          <a:noFill/>
-          <a:ln/>
-        </p:spPr>
-        <p:txBody>
-          <a:bodyPr wrap="square" rtlCol="0" anchor="ctr"/>
-          <a:lstStyle/>
-          <a:p>
-            <a:pPr indent="0" marL="0">
-              <a:buNone/>
-            </a:pPr>
-            <a:r>
-              <a:rPr lang="en-US" sz="1300" dirty="0">
-                <a:solidFill>
-                  <a:srgbClr val="6B6B6B"/>
+          <p:cNvPr id="9" name="Text 7"/>
+          <p:cNvSpPr/>
+          <p:nvPr/>
+        </p:nvSpPr>
+        <p:spPr>
+          <a:xfrm>
+            <a:off x="4617720" y="2834640"/>
+            <a:ext cx="2834640" cy="1371600"/>
+          </a:xfrm>
+          <a:prstGeom prst="rect">
+            <a:avLst/>
+          </a:prstGeom>
+          <a:noFill/>
+          <a:ln/>
+        </p:spPr>
+        <p:txBody>
+          <a:bodyPr wrap="square" rtlCol="0" anchor="t"/>
+          <a:lstStyle/>
+          <a:p>
+            <a:pPr indent="0" marL="0">
+              <a:buNone/>
+            </a:pPr>
+            <a:r>
+              <a:rPr lang="en-US" sz="1250" dirty="0">
+                <a:solidFill>
+                  <a:srgbClr val="2A2A2A"/>
                 </a:solidFill>
                 <a:latin typeface="Calibri" pitchFamily="34" charset="0"/>
                 <a:ea typeface="Calibri" pitchFamily="34" charset="-122"/>
                 <a:cs typeface="Calibri" pitchFamily="34" charset="-120"/>
               </a:rPr>
-              <a:t>Common fixes, worth naming before they come up:</a:t>
-            </a:r>
-            <a:endParaRPr lang="en-US" sz="1300" dirty="0"/>
-          </a:p>
-        </p:txBody>
-      </p:sp>
-      <p:sp>
-        <p:nvSpPr>
-          <p:cNvPr id="7" name="Text 5"/>
-          <p:cNvSpPr/>
-          <p:nvPr/>
-        </p:nvSpPr>
-        <p:spPr>
-          <a:xfrm>
-            <a:off x="822960" y="3931920"/>
-            <a:ext cx="9875520" cy="365760"/>
+              <a:t>drag fields here to build the chart</a:t>
+            </a:r>
+            <a:endParaRPr lang="en-US" sz="1250" dirty="0"/>
+          </a:p>
+        </p:txBody>
+      </p:sp>
+      <p:sp>
+        <p:nvSpPr>
+          <p:cNvPr id="10" name="Shape 8"/>
+          <p:cNvSpPr/>
+          <p:nvPr/>
+        </p:nvSpPr>
+        <p:spPr>
+          <a:xfrm>
+            <a:off x="8046720" y="2011680"/>
+            <a:ext cx="3383280" cy="2377440"/>
+          </a:xfrm>
+          <a:prstGeom prst="rect">
+            <a:avLst/>
+          </a:prstGeom>
+          <a:solidFill>
+            <a:srgbClr val="F4F1EC"/>
+          </a:solidFill>
+          <a:ln/>
+        </p:spPr>
+      </p:sp>
+      <p:sp>
+        <p:nvSpPr>
+          <p:cNvPr id="11" name="Text 9"/>
+          <p:cNvSpPr/>
+          <p:nvPr/>
+        </p:nvSpPr>
+        <p:spPr>
+          <a:xfrm>
+            <a:off x="8321040" y="2240280"/>
+            <a:ext cx="2834640" cy="548640"/>
           </a:xfrm>
           <a:prstGeom prst="rect">
             <a:avLst/>
@@ -3225,7 +3345,46 @@
               <a:buNone/>
             </a:pPr>
             <a:r>
-              <a:rPr lang="en-US" sz="1400" dirty="0">
+              <a:rPr lang="en-US" sz="1700" b="1" dirty="0">
+                <a:solidFill>
+                  <a:srgbClr val="1C3F60"/>
+                </a:solidFill>
+                <a:latin typeface="Georgia" pitchFamily="34" charset="0"/>
+                <a:ea typeface="Georgia" pitchFamily="34" charset="-122"/>
+                <a:cs typeface="Georgia" pitchFamily="34" charset="-120"/>
+              </a:rPr>
+              <a:t>Marks card</a:t>
+            </a:r>
+            <a:endParaRPr lang="en-US" sz="1700" dirty="0"/>
+          </a:p>
+        </p:txBody>
+      </p:sp>
+      <p:sp>
+        <p:nvSpPr>
+          <p:cNvPr id="12" name="Text 10"/>
+          <p:cNvSpPr/>
+          <p:nvPr/>
+        </p:nvSpPr>
+        <p:spPr>
+          <a:xfrm>
+            <a:off x="8321040" y="2834640"/>
+            <a:ext cx="2834640" cy="1371600"/>
+          </a:xfrm>
+          <a:prstGeom prst="rect">
+            <a:avLst/>
+          </a:prstGeom>
+          <a:noFill/>
+          <a:ln/>
+        </p:spPr>
+        <p:txBody>
+          <a:bodyPr wrap="square" rtlCol="0" anchor="t"/>
+          <a:lstStyle/>
+          <a:p>
+            <a:pPr indent="0" marL="0">
+              <a:buNone/>
+            </a:pPr>
+            <a:r>
+              <a:rPr lang="en-US" sz="1250" dirty="0">
                 <a:solidFill>
                   <a:srgbClr val="2A2A2A"/>
                 </a:solidFill>
@@ -3233,22 +3392,22 @@
                 <a:ea typeface="Calibri" pitchFamily="34" charset="-122"/>
                 <a:cs typeface="Calibri" pitchFamily="34" charset="-120"/>
               </a:rPr>
-              <a:t>•  Unlabeled axes</a:t>
-            </a:r>
-            <a:endParaRPr lang="en-US" sz="1400" dirty="0"/>
-          </a:p>
-        </p:txBody>
-      </p:sp>
-      <p:sp>
-        <p:nvSpPr>
-          <p:cNvPr id="8" name="Text 6"/>
-          <p:cNvSpPr/>
-          <p:nvPr/>
-        </p:nvSpPr>
-        <p:spPr>
-          <a:xfrm>
-            <a:off x="822960" y="4315968"/>
-            <a:ext cx="9875520" cy="365760"/>
+              <a:t>color, size, label, detail, tooltip</a:t>
+            </a:r>
+            <a:endParaRPr lang="en-US" sz="1250" dirty="0"/>
+          </a:p>
+        </p:txBody>
+      </p:sp>
+      <p:sp>
+        <p:nvSpPr>
+          <p:cNvPr id="13" name="Text 11"/>
+          <p:cNvSpPr/>
+          <p:nvPr/>
+        </p:nvSpPr>
+        <p:spPr>
+          <a:xfrm>
+            <a:off x="640080" y="4754880"/>
+            <a:ext cx="10515600" cy="914400"/>
           </a:xfrm>
           <a:prstGeom prst="rect">
             <a:avLst/>
@@ -3264,93 +3423,15 @@
               <a:buNone/>
             </a:pPr>
             <a:r>
-              <a:rPr lang="en-US" sz="1400" dirty="0">
-                <a:solidFill>
-                  <a:srgbClr val="2A2A2A"/>
+              <a:rPr lang="en-US" sz="1400" i="1" dirty="0">
+                <a:solidFill>
+                  <a:srgbClr val="6B6B6B"/>
                 </a:solidFill>
                 <a:latin typeface="Calibri" pitchFamily="34" charset="0"/>
                 <a:ea typeface="Calibri" pitchFamily="34" charset="-122"/>
                 <a:cs typeface="Calibri" pitchFamily="34" charset="-120"/>
               </a:rPr>
-              <a:t>•  A color scheme with no clear meaning</a:t>
-            </a:r>
-            <a:endParaRPr lang="en-US" sz="1400" dirty="0"/>
-          </a:p>
-        </p:txBody>
-      </p:sp>
-      <p:sp>
-        <p:nvSpPr>
-          <p:cNvPr id="9" name="Text 7"/>
-          <p:cNvSpPr/>
-          <p:nvPr/>
-        </p:nvSpPr>
-        <p:spPr>
-          <a:xfrm>
-            <a:off x="822960" y="4700016"/>
-            <a:ext cx="9875520" cy="365760"/>
-          </a:xfrm>
-          <a:prstGeom prst="rect">
-            <a:avLst/>
-          </a:prstGeom>
-          <a:noFill/>
-          <a:ln/>
-        </p:spPr>
-        <p:txBody>
-          <a:bodyPr wrap="square" rtlCol="0" anchor="ctr"/>
-          <a:lstStyle/>
-          <a:p>
-            <a:pPr indent="0" marL="0">
-              <a:buNone/>
-            </a:pPr>
-            <a:r>
-              <a:rPr lang="en-US" sz="1400" dirty="0">
-                <a:solidFill>
-                  <a:srgbClr val="2A2A2A"/>
-                </a:solidFill>
-                <a:latin typeface="Calibri" pitchFamily="34" charset="0"/>
-                <a:ea typeface="Calibri" pitchFamily="34" charset="-122"/>
-                <a:cs typeface="Calibri" pitchFamily="34" charset="-120"/>
-              </a:rPr>
-              <a:t>•  Too many visuals competing for attention</a:t>
-            </a:r>
-            <a:endParaRPr lang="en-US" sz="1400" dirty="0"/>
-          </a:p>
-        </p:txBody>
-      </p:sp>
-      <p:sp>
-        <p:nvSpPr>
-          <p:cNvPr id="10" name="Text 8"/>
-          <p:cNvSpPr/>
-          <p:nvPr/>
-        </p:nvSpPr>
-        <p:spPr>
-          <a:xfrm>
-            <a:off x="822960" y="5084064"/>
-            <a:ext cx="9875520" cy="365760"/>
-          </a:xfrm>
-          <a:prstGeom prst="rect">
-            <a:avLst/>
-          </a:prstGeom>
-          <a:noFill/>
-          <a:ln/>
-        </p:spPr>
-        <p:txBody>
-          <a:bodyPr wrap="square" rtlCol="0" anchor="ctr"/>
-          <a:lstStyle/>
-          <a:p>
-            <a:pPr indent="0" marL="0">
-              <a:buNone/>
-            </a:pPr>
-            <a:r>
-              <a:rPr lang="en-US" sz="1400" dirty="0">
-                <a:solidFill>
-                  <a:srgbClr val="2A2A2A"/>
-                </a:solidFill>
-                <a:latin typeface="Calibri" pitchFamily="34" charset="0"/>
-                <a:ea typeface="Calibri" pitchFamily="34" charset="-122"/>
-                <a:cs typeface="Calibri" pitchFamily="34" charset="-120"/>
-              </a:rPr>
-              <a:t>•  A title that names the chart type, not the finding</a:t>
+              <a:t>First build, live: Major_category → Columns, average Median → Rows. Then a scatter: ShareWomen vs. Median, colored by Major_category.</a:t>
             </a:r>
             <a:endParaRPr lang="en-US" sz="1400" dirty="0"/>
           </a:p>
@@ -3421,7 +3502,7 @@
                 <a:ea typeface="Calibri" pitchFamily="34" charset="-122"/>
                 <a:cs typeface="Calibri" pitchFamily="34" charset="-120"/>
               </a:rPr>
-              <a:t>NEXT WEEK</a:t>
+              <a:t>GUIDED BUILD — 25 MIN</a:t>
             </a:r>
             <a:endParaRPr lang="en-US" sz="1200" dirty="0"/>
           </a:p>
@@ -3452,17 +3533,17 @@
               <a:buNone/>
             </a:pPr>
             <a:r>
-              <a:rPr lang="en-US" sz="2700" b="1" dirty="0">
-                <a:solidFill>
-                  <a:srgbClr val="1B3A34"/>
+              <a:rPr lang="en-US" sz="2600" b="1" dirty="0">
+                <a:solidFill>
+                  <a:srgbClr val="1C3F60"/>
                 </a:solidFill>
                 <a:latin typeface="Georgia" pitchFamily="34" charset="0"/>
                 <a:ea typeface="Georgia" pitchFamily="34" charset="-122"/>
                 <a:cs typeface="Georgia" pitchFamily="34" charset="-120"/>
               </a:rPr>
-              <a:t>Week 4 is yours</a:t>
-            </a:r>
-            <a:endParaRPr lang="en-US" sz="2700" dirty="0"/>
+              <a:t>Rebuild, combine, filter</a:t>
+            </a:r>
+            <a:endParaRPr lang="en-US" sz="2600" dirty="0"/>
           </a:p>
         </p:txBody>
       </p:sp>
@@ -3474,8 +3555,8 @@
         </p:nvSpPr>
         <p:spPr>
           <a:xfrm>
-            <a:off x="640080" y="2103120"/>
-            <a:ext cx="10058400" cy="914400"/>
+            <a:off x="640080" y="2011680"/>
+            <a:ext cx="502920" cy="502920"/>
           </a:xfrm>
           <a:prstGeom prst="rect">
             <a:avLst/>
@@ -3491,17 +3572,17 @@
               <a:buNone/>
             </a:pPr>
             <a:r>
-              <a:rPr lang="en-US" sz="2200" b="1" dirty="0">
-                <a:solidFill>
-                  <a:srgbClr val="1B3A34"/>
+              <a:rPr lang="en-US" sz="2000" b="1" dirty="0">
+                <a:solidFill>
+                  <a:srgbClr val="D97E3F"/>
                 </a:solidFill>
                 <a:latin typeface="Georgia" pitchFamily="34" charset="0"/>
                 <a:ea typeface="Georgia" pitchFamily="34" charset="-122"/>
                 <a:cs typeface="Georgia" pitchFamily="34" charset="-120"/>
               </a:rPr>
-              <a:t>Same dataset. Your own question, from scratch. Excel + Power BI, no script.</a:t>
-            </a:r>
-            <a:endParaRPr lang="en-US" sz="2200" dirty="0"/>
+              <a:t>1</a:t>
+            </a:r>
+            <a:endParaRPr lang="en-US" sz="2000" dirty="0"/>
           </a:p>
         </p:txBody>
       </p:sp>
@@ -3513,8 +3594,8 @@
         </p:nvSpPr>
         <p:spPr>
           <a:xfrm>
-            <a:off x="640080" y="3200400"/>
-            <a:ext cx="9875520" cy="731520"/>
+            <a:off x="1188720" y="2039112"/>
+            <a:ext cx="9966960" cy="502920"/>
           </a:xfrm>
           <a:prstGeom prst="rect">
             <a:avLst/>
@@ -3530,7 +3611,7 @@
               <a:buNone/>
             </a:pPr>
             <a:r>
-              <a:rPr lang="en-US" sz="1500" dirty="0">
+              <a:rPr lang="en-US" sz="1600" dirty="0">
                 <a:solidFill>
                   <a:srgbClr val="2A2A2A"/>
                 </a:solidFill>
@@ -3538,9 +3619,9 @@
                 <a:ea typeface="Calibri" pitchFamily="34" charset="-122"/>
                 <a:cs typeface="Calibri" pitchFamily="34" charset="-120"/>
               </a:rPr>
-              <a:t>Everything the last two weeks taught you, now without a script — presented to the rest of the branch.</a:t>
-            </a:r>
-            <a:endParaRPr lang="en-US" sz="1500" dirty="0"/>
+              <a:t>Rebuild both charts from the demo</a:t>
+            </a:r>
+            <a:endParaRPr lang="en-US" sz="1600" dirty="0"/>
           </a:p>
         </p:txBody>
       </p:sp>
@@ -3552,8 +3633,8 @@
         </p:nvSpPr>
         <p:spPr>
           <a:xfrm>
-            <a:off x="640080" y="6035040"/>
-            <a:ext cx="7315200" cy="365760"/>
+            <a:off x="640080" y="2788920"/>
+            <a:ext cx="502920" cy="502920"/>
           </a:xfrm>
           <a:prstGeom prst="rect">
             <a:avLst/>
@@ -3569,17 +3650,520 @@
               <a:buNone/>
             </a:pPr>
             <a:r>
-              <a:rPr lang="en-US" sz="1100" b="1" spc="200" kern="0" dirty="0">
-                <a:solidFill>
-                  <a:srgbClr val="6B6B6B"/>
+              <a:rPr lang="en-US" sz="2000" b="1" dirty="0">
+                <a:solidFill>
+                  <a:srgbClr val="D97E3F"/>
+                </a:solidFill>
+                <a:latin typeface="Georgia" pitchFamily="34" charset="0"/>
+                <a:ea typeface="Georgia" pitchFamily="34" charset="-122"/>
+                <a:cs typeface="Georgia" pitchFamily="34" charset="-120"/>
+              </a:rPr>
+              <a:t>2</a:t>
+            </a:r>
+            <a:endParaRPr lang="en-US" sz="2000" dirty="0"/>
+          </a:p>
+        </p:txBody>
+      </p:sp>
+      <p:sp>
+        <p:nvSpPr>
+          <p:cNvPr id="7" name="Text 5"/>
+          <p:cNvSpPr/>
+          <p:nvPr/>
+        </p:nvSpPr>
+        <p:spPr>
+          <a:xfrm>
+            <a:off x="1188720" y="2816352"/>
+            <a:ext cx="9966960" cy="502920"/>
+          </a:xfrm>
+          <a:prstGeom prst="rect">
+            <a:avLst/>
+          </a:prstGeom>
+          <a:noFill/>
+          <a:ln/>
+        </p:spPr>
+        <p:txBody>
+          <a:bodyPr wrap="square" rtlCol="0" anchor="ctr"/>
+          <a:lstStyle/>
+          <a:p>
+            <a:pPr indent="0" marL="0">
+              <a:buNone/>
+            </a:pPr>
+            <a:r>
+              <a:rPr lang="en-US" sz="1600" dirty="0">
+                <a:solidFill>
+                  <a:srgbClr val="2A2A2A"/>
                 </a:solidFill>
                 <a:latin typeface="Calibri" pitchFamily="34" charset="0"/>
                 <a:ea typeface="Calibri" pitchFamily="34" charset="-122"/>
                 <a:cs typeface="Calibri" pitchFamily="34" charset="-120"/>
               </a:rPr>
-              <a:t>DSDG DATA ANALYTICS</a:t>
-            </a:r>
-            <a:endParaRPr lang="en-US" sz="1100" dirty="0"/>
+              <a:t>Combine them on a new Dashboard</a:t>
+            </a:r>
+            <a:endParaRPr lang="en-US" sz="1600" dirty="0"/>
+          </a:p>
+        </p:txBody>
+      </p:sp>
+      <p:sp>
+        <p:nvSpPr>
+          <p:cNvPr id="8" name="Text 6"/>
+          <p:cNvSpPr/>
+          <p:nvPr/>
+        </p:nvSpPr>
+        <p:spPr>
+          <a:xfrm>
+            <a:off x="640080" y="3566160"/>
+            <a:ext cx="502920" cy="502920"/>
+          </a:xfrm>
+          <a:prstGeom prst="rect">
+            <a:avLst/>
+          </a:prstGeom>
+          <a:noFill/>
+          <a:ln/>
+        </p:spPr>
+        <p:txBody>
+          <a:bodyPr wrap="square" rtlCol="0" anchor="ctr"/>
+          <a:lstStyle/>
+          <a:p>
+            <a:pPr indent="0" marL="0">
+              <a:buNone/>
+            </a:pPr>
+            <a:r>
+              <a:rPr lang="en-US" sz="2000" b="1" dirty="0">
+                <a:solidFill>
+                  <a:srgbClr val="D97E3F"/>
+                </a:solidFill>
+                <a:latin typeface="Georgia" pitchFamily="34" charset="0"/>
+                <a:ea typeface="Georgia" pitchFamily="34" charset="-122"/>
+                <a:cs typeface="Georgia" pitchFamily="34" charset="-120"/>
+              </a:rPr>
+              <a:t>3</a:t>
+            </a:r>
+            <a:endParaRPr lang="en-US" sz="2000" dirty="0"/>
+          </a:p>
+        </p:txBody>
+      </p:sp>
+      <p:sp>
+        <p:nvSpPr>
+          <p:cNvPr id="9" name="Text 7"/>
+          <p:cNvSpPr/>
+          <p:nvPr/>
+        </p:nvSpPr>
+        <p:spPr>
+          <a:xfrm>
+            <a:off x="1188720" y="3593592"/>
+            <a:ext cx="9966960" cy="502920"/>
+          </a:xfrm>
+          <a:prstGeom prst="rect">
+            <a:avLst/>
+          </a:prstGeom>
+          <a:noFill/>
+          <a:ln/>
+        </p:spPr>
+        <p:txBody>
+          <a:bodyPr wrap="square" rtlCol="0" anchor="ctr"/>
+          <a:lstStyle/>
+          <a:p>
+            <a:pPr indent="0" marL="0">
+              <a:buNone/>
+            </a:pPr>
+            <a:r>
+              <a:rPr lang="en-US" sz="1600" dirty="0">
+                <a:solidFill>
+                  <a:srgbClr val="2A2A2A"/>
+                </a:solidFill>
+                <a:latin typeface="Calibri" pitchFamily="34" charset="0"/>
+                <a:ea typeface="Calibri" pitchFamily="34" charset="-122"/>
+                <a:cs typeface="Calibri" pitchFamily="34" charset="-120"/>
+              </a:rPr>
+              <a:t>Add a filter on Major_category, apply it to all sheets</a:t>
+            </a:r>
+            <a:endParaRPr lang="en-US" sz="1600" dirty="0"/>
+          </a:p>
+        </p:txBody>
+      </p:sp>
+      <p:sp>
+        <p:nvSpPr>
+          <p:cNvPr id="10" name="Text 8"/>
+          <p:cNvSpPr/>
+          <p:nvPr/>
+        </p:nvSpPr>
+        <p:spPr>
+          <a:xfrm>
+            <a:off x="640080" y="4343400"/>
+            <a:ext cx="502920" cy="502920"/>
+          </a:xfrm>
+          <a:prstGeom prst="rect">
+            <a:avLst/>
+          </a:prstGeom>
+          <a:noFill/>
+          <a:ln/>
+        </p:spPr>
+        <p:txBody>
+          <a:bodyPr wrap="square" rtlCol="0" anchor="ctr"/>
+          <a:lstStyle/>
+          <a:p>
+            <a:pPr indent="0" marL="0">
+              <a:buNone/>
+            </a:pPr>
+            <a:r>
+              <a:rPr lang="en-US" sz="2000" b="1" dirty="0">
+                <a:solidFill>
+                  <a:srgbClr val="D97E3F"/>
+                </a:solidFill>
+                <a:latin typeface="Georgia" pitchFamily="34" charset="0"/>
+                <a:ea typeface="Georgia" pitchFamily="34" charset="-122"/>
+                <a:cs typeface="Georgia" pitchFamily="34" charset="-120"/>
+              </a:rPr>
+              <a:t>4</a:t>
+            </a:r>
+            <a:endParaRPr lang="en-US" sz="2000" dirty="0"/>
+          </a:p>
+        </p:txBody>
+      </p:sp>
+      <p:sp>
+        <p:nvSpPr>
+          <p:cNvPr id="11" name="Text 9"/>
+          <p:cNvSpPr/>
+          <p:nvPr/>
+        </p:nvSpPr>
+        <p:spPr>
+          <a:xfrm>
+            <a:off x="1188720" y="4370832"/>
+            <a:ext cx="9966960" cy="502920"/>
+          </a:xfrm>
+          <a:prstGeom prst="rect">
+            <a:avLst/>
+          </a:prstGeom>
+          <a:noFill/>
+          <a:ln/>
+        </p:spPr>
+        <p:txBody>
+          <a:bodyPr wrap="square" rtlCol="0" anchor="ctr"/>
+          <a:lstStyle/>
+          <a:p>
+            <a:pPr indent="0" marL="0">
+              <a:buNone/>
+            </a:pPr>
+            <a:r>
+              <a:rPr lang="en-US" sz="1600" dirty="0">
+                <a:solidFill>
+                  <a:srgbClr val="2A2A2A"/>
+                </a:solidFill>
+                <a:latin typeface="Calibri" pitchFamily="34" charset="0"/>
+                <a:ea typeface="Calibri" pitchFamily="34" charset="-122"/>
+                <a:cs typeface="Calibri" pitchFamily="34" charset="-120"/>
+              </a:rPr>
+              <a:t>Your choice: a third visual, ideally your Week 2 column as a calculated field</a:t>
+            </a:r>
+            <a:endParaRPr lang="en-US" sz="1600" dirty="0"/>
+          </a:p>
+        </p:txBody>
+      </p:sp>
+      <p:sp>
+        <p:nvSpPr>
+          <p:cNvPr id="12" name="Text 10"/>
+          <p:cNvSpPr/>
+          <p:nvPr/>
+        </p:nvSpPr>
+        <p:spPr>
+          <a:xfrm>
+            <a:off x="640080" y="5212080"/>
+            <a:ext cx="10058400" cy="457200"/>
+          </a:xfrm>
+          <a:prstGeom prst="rect">
+            <a:avLst/>
+          </a:prstGeom>
+          <a:noFill/>
+          <a:ln/>
+        </p:spPr>
+        <p:txBody>
+          <a:bodyPr wrap="square" rtlCol="0" anchor="ctr"/>
+          <a:lstStyle/>
+          <a:p>
+            <a:pPr indent="0" marL="0">
+              <a:buNone/>
+            </a:pPr>
+            <a:r>
+              <a:rPr lang="en-US" sz="1400" b="1" i="1" dirty="0">
+                <a:solidFill>
+                  <a:srgbClr val="1C3F60"/>
+                </a:solidFill>
+                <a:latin typeface="Calibri" pitchFamily="34" charset="0"/>
+                <a:ea typeface="Calibri" pitchFamily="34" charset="-122"/>
+                <a:cs typeface="Calibri" pitchFamily="34" charset="-120"/>
+              </a:rPr>
+              <a:t>Every chart needs a title that states the finding, not the chart type.</a:t>
+            </a:r>
+            <a:endParaRPr lang="en-US" sz="1400" dirty="0"/>
+          </a:p>
+        </p:txBody>
+      </p:sp>
+    </p:spTree>
+  </p:cSld>
+  <p:clrMapOvr>
+    <a:masterClrMapping/>
+  </p:clrMapOvr>
+</p:sld>
+</file>
+
+<file path=ppt/slides/slide8.xml><?xml version="1.0" encoding="utf-8"?>
+<p:sld xmlns:a="http://schemas.openxmlformats.org/drawingml/2006/main" xmlns:r="http://schemas.openxmlformats.org/officeDocument/2006/relationships" xmlns:p="http://schemas.openxmlformats.org/presentationml/2006/main">
+  <p:cSld name="Slide 8">
+    <p:bg>
+      <p:bgPr>
+        <a:solidFill>
+          <a:srgbClr val="FFFFFF"/>
+        </a:solidFill>
+      </p:bgPr>
+    </p:bg>
+    <p:spTree>
+      <p:nvGrpSpPr>
+        <p:cNvPr id="1" name=""/>
+        <p:cNvGrpSpPr/>
+        <p:nvPr/>
+      </p:nvGrpSpPr>
+      <p:grpSpPr>
+        <a:xfrm>
+          <a:off x="0" y="0"/>
+          <a:ext cx="0" cy="0"/>
+          <a:chOff x="0" y="0"/>
+          <a:chExt cx="0" cy="0"/>
+        </a:xfrm>
+      </p:grpSpPr>
+      <p:sp>
+        <p:nvSpPr>
+          <p:cNvPr id="2" name="Text 0"/>
+          <p:cNvSpPr/>
+          <p:nvPr/>
+        </p:nvSpPr>
+        <p:spPr>
+          <a:xfrm>
+            <a:off x="640080" y="457200"/>
+            <a:ext cx="9144000" cy="365760"/>
+          </a:xfrm>
+          <a:prstGeom prst="rect">
+            <a:avLst/>
+          </a:prstGeom>
+          <a:noFill/>
+          <a:ln/>
+        </p:spPr>
+        <p:txBody>
+          <a:bodyPr wrap="square" rtlCol="0" anchor="ctr"/>
+          <a:lstStyle/>
+          <a:p>
+            <a:pPr indent="0" marL="0">
+              <a:buNone/>
+            </a:pPr>
+            <a:r>
+              <a:rPr lang="en-US" sz="1200" b="1" spc="200" kern="0" dirty="0">
+                <a:solidFill>
+                  <a:srgbClr val="D97E3F"/>
+                </a:solidFill>
+                <a:latin typeface="Calibri" pitchFamily="34" charset="0"/>
+                <a:ea typeface="Calibri" pitchFamily="34" charset="-122"/>
+                <a:cs typeface="Calibri" pitchFamily="34" charset="-120"/>
+              </a:rPr>
+              <a:t>THE FIVE-SECOND TEST</a:t>
+            </a:r>
+            <a:endParaRPr lang="en-US" sz="1200" dirty="0"/>
+          </a:p>
+        </p:txBody>
+      </p:sp>
+      <p:sp>
+        <p:nvSpPr>
+          <p:cNvPr id="3" name="Text 1"/>
+          <p:cNvSpPr/>
+          <p:nvPr/>
+        </p:nvSpPr>
+        <p:spPr>
+          <a:xfrm>
+            <a:off x="640080" y="777240"/>
+            <a:ext cx="10515600" cy="822960"/>
+          </a:xfrm>
+          <a:prstGeom prst="rect">
+            <a:avLst/>
+          </a:prstGeom>
+          <a:noFill/>
+          <a:ln/>
+        </p:spPr>
+        <p:txBody>
+          <a:bodyPr wrap="square" rtlCol="0" anchor="ctr"/>
+          <a:lstStyle/>
+          <a:p>
+            <a:pPr indent="0" marL="0">
+              <a:buNone/>
+            </a:pPr>
+            <a:r>
+              <a:rPr lang="en-US" sz="2600" b="1" dirty="0">
+                <a:solidFill>
+                  <a:srgbClr val="1C3F60"/>
+                </a:solidFill>
+                <a:latin typeface="Georgia" pitchFamily="34" charset="0"/>
+                <a:ea typeface="Georgia" pitchFamily="34" charset="-122"/>
+                <a:cs typeface="Georgia" pitchFamily="34" charset="-120"/>
+              </a:rPr>
+              <a:t>Critique, then look ahead</a:t>
+            </a:r>
+            <a:endParaRPr lang="en-US" sz="2600" dirty="0"/>
+          </a:p>
+        </p:txBody>
+      </p:sp>
+      <p:sp>
+        <p:nvSpPr>
+          <p:cNvPr id="4" name="Shape 2"/>
+          <p:cNvSpPr/>
+          <p:nvPr/>
+        </p:nvSpPr>
+        <p:spPr>
+          <a:xfrm>
+            <a:off x="640080" y="1874520"/>
+            <a:ext cx="10881360" cy="1005840"/>
+          </a:xfrm>
+          <a:prstGeom prst="roundRect">
+            <a:avLst>
+              <a:gd name="adj" fmla="val 5455"/>
+            </a:avLst>
+          </a:prstGeom>
+          <a:solidFill>
+            <a:srgbClr val="1C3F60"/>
+          </a:solidFill>
+          <a:ln/>
+        </p:spPr>
+      </p:sp>
+      <p:sp>
+        <p:nvSpPr>
+          <p:cNvPr id="5" name="Text 3"/>
+          <p:cNvSpPr/>
+          <p:nvPr/>
+        </p:nvSpPr>
+        <p:spPr>
+          <a:xfrm>
+            <a:off x="1005840" y="1874520"/>
+            <a:ext cx="10149840" cy="1005840"/>
+          </a:xfrm>
+          <a:prstGeom prst="rect">
+            <a:avLst/>
+          </a:prstGeom>
+          <a:noFill/>
+          <a:ln/>
+        </p:spPr>
+        <p:txBody>
+          <a:bodyPr wrap="square" rtlCol="0" anchor="ctr"/>
+          <a:lstStyle/>
+          <a:p>
+            <a:pPr algn="ctr" indent="0" marL="0">
+              <a:buNone/>
+            </a:pPr>
+            <a:r>
+              <a:rPr lang="en-US" sz="1700" b="1" dirty="0">
+                <a:solidFill>
+                  <a:srgbClr val="FFFFFF"/>
+                </a:solidFill>
+                <a:latin typeface="Calibri" pitchFamily="34" charset="0"/>
+                <a:ea typeface="Calibri" pitchFamily="34" charset="-122"/>
+                <a:cs typeface="Calibri" pitchFamily="34" charset="-120"/>
+              </a:rPr>
+              <a:t>What would you understand from this in five seconds, cold?</a:t>
+            </a:r>
+            <a:endParaRPr lang="en-US" sz="1700" dirty="0"/>
+          </a:p>
+        </p:txBody>
+      </p:sp>
+      <p:sp>
+        <p:nvSpPr>
+          <p:cNvPr id="6" name="Text 4"/>
+          <p:cNvSpPr/>
+          <p:nvPr/>
+        </p:nvSpPr>
+        <p:spPr>
+          <a:xfrm>
+            <a:off x="640080" y="3108960"/>
+            <a:ext cx="10332720" cy="731520"/>
+          </a:xfrm>
+          <a:prstGeom prst="rect">
+            <a:avLst/>
+          </a:prstGeom>
+          <a:noFill/>
+          <a:ln/>
+        </p:spPr>
+        <p:txBody>
+          <a:bodyPr wrap="square" rtlCol="0" anchor="ctr"/>
+          <a:lstStyle/>
+          <a:p>
+            <a:pPr indent="0" marL="0">
+              <a:buNone/>
+            </a:pPr>
+            <a:r>
+              <a:rPr lang="en-US" sz="1350" dirty="0">
+                <a:solidFill>
+                  <a:srgbClr val="2A2A2A"/>
+                </a:solidFill>
+                <a:latin typeface="Calibri" pitchFamily="34" charset="0"/>
+                <a:ea typeface="Calibri" pitchFamily="34" charset="-122"/>
+                <a:cs typeface="Calibri" pitchFamily="34" charset="-120"/>
+              </a:rPr>
+              <a:t>Common fixes: unlabeled axes, no clear color meaning, too many charts, a title naming the chart type instead of the finding.</a:t>
+            </a:r>
+            <a:endParaRPr lang="en-US" sz="1350" dirty="0"/>
+          </a:p>
+        </p:txBody>
+      </p:sp>
+      <p:sp>
+        <p:nvSpPr>
+          <p:cNvPr id="7" name="Shape 5"/>
+          <p:cNvSpPr/>
+          <p:nvPr/>
+        </p:nvSpPr>
+        <p:spPr>
+          <a:xfrm>
+            <a:off x="640080" y="4114800"/>
+            <a:ext cx="10881360" cy="18288"/>
+          </a:xfrm>
+          <a:prstGeom prst="rect">
+            <a:avLst/>
+          </a:prstGeom>
+          <a:solidFill>
+            <a:srgbClr val="5B8A82"/>
+          </a:solidFill>
+          <a:ln/>
+        </p:spPr>
+      </p:sp>
+      <p:sp>
+        <p:nvSpPr>
+          <p:cNvPr id="8" name="Text 6"/>
+          <p:cNvSpPr/>
+          <p:nvPr/>
+        </p:nvSpPr>
+        <p:spPr>
+          <a:xfrm>
+            <a:off x="640080" y="4434840"/>
+            <a:ext cx="10058400" cy="640080"/>
+          </a:xfrm>
+          <a:prstGeom prst="rect">
+            <a:avLst/>
+          </a:prstGeom>
+          <a:noFill/>
+          <a:ln/>
+        </p:spPr>
+        <p:txBody>
+          <a:bodyPr wrap="square" rtlCol="0" anchor="ctr"/>
+          <a:lstStyle/>
+          <a:p>
+            <a:pPr indent="0" marL="0">
+              <a:buNone/>
+            </a:pPr>
+            <a:r>
+              <a:rPr lang="en-US" sz="1800" b="1" dirty="0">
+                <a:solidFill>
+                  <a:srgbClr val="1C3F60"/>
+                </a:solidFill>
+                <a:latin typeface="Georgia" pitchFamily="34" charset="0"/>
+                <a:ea typeface="Georgia" pitchFamily="34" charset="-122"/>
+                <a:cs typeface="Georgia" pitchFamily="34" charset="-120"/>
+              </a:rPr>
+              <a:t>Week 4 is yours: same dataset, your own question, Excel and Tableau together, no script.</a:t>
+            </a:r>
+            <a:endParaRPr lang="en-US" sz="1800" dirty="0"/>
           </a:p>
         </p:txBody>
       </p:sp>

</xml_diff>